<commit_message>
updated ppt with new features
</commit_message>
<xml_diff>
--- a/docs/AgentForge-Presentation.pptx
+++ b/docs/AgentForge-Presentation.pptx
@@ -5,26 +5,26 @@
     <p:sldMasterId id="2147483648" r:id="rId1"/>
   </p:sldMasterIdLst>
   <p:sldIdLst>
-    <p:sldId id="256" r:id="rId7"/>
-    <p:sldId id="257" r:id="rId8"/>
-    <p:sldId id="258" r:id="rId9"/>
-    <p:sldId id="259" r:id="rId10"/>
-    <p:sldId id="260" r:id="rId11"/>
-    <p:sldId id="261" r:id="rId12"/>
-    <p:sldId id="262" r:id="rId13"/>
-    <p:sldId id="263" r:id="rId14"/>
-    <p:sldId id="264" r:id="rId15"/>
-    <p:sldId id="265" r:id="rId16"/>
-    <p:sldId id="266" r:id="rId17"/>
-    <p:sldId id="267" r:id="rId18"/>
-    <p:sldId id="268" r:id="rId19"/>
-    <p:sldId id="269" r:id="rId20"/>
-    <p:sldId id="270" r:id="rId21"/>
-    <p:sldId id="271" r:id="rId22"/>
-    <p:sldId id="272" r:id="rId23"/>
-    <p:sldId id="273" r:id="rId24"/>
+    <p:sldId id="256" r:id="rId2"/>
+    <p:sldId id="257" r:id="rId3"/>
+    <p:sldId id="258" r:id="rId4"/>
+    <p:sldId id="259" r:id="rId5"/>
+    <p:sldId id="260" r:id="rId6"/>
+    <p:sldId id="261" r:id="rId7"/>
+    <p:sldId id="262" r:id="rId8"/>
+    <p:sldId id="263" r:id="rId9"/>
+    <p:sldId id="264" r:id="rId10"/>
+    <p:sldId id="265" r:id="rId11"/>
+    <p:sldId id="266" r:id="rId12"/>
+    <p:sldId id="267" r:id="rId13"/>
+    <p:sldId id="268" r:id="rId14"/>
+    <p:sldId id="269" r:id="rId15"/>
+    <p:sldId id="270" r:id="rId16"/>
+    <p:sldId id="271" r:id="rId17"/>
+    <p:sldId id="272" r:id="rId18"/>
+    <p:sldId id="273" r:id="rId19"/>
   </p:sldIdLst>
-  <p:sldSz cx="12188952" cy="6858000" type="screen4x3"/>
+  <p:sldSz cx="12188825" cy="6858000"/>
   <p:notesSz cx="6858000" cy="9144000"/>
   <p:defaultTextStyle>
     <a:defPPr>
@@ -121,6 +121,22 @@
       </a:defRPr>
     </a:lvl9pPr>
   </p:defaultTextStyle>
+  <p:extLst>
+    <p:ext uri="{EFAFB233-063F-42B5-8137-9DF3F51BA10A}">
+      <p15:sldGuideLst xmlns:p15="http://schemas.microsoft.com/office/powerpoint/2012/main">
+        <p15:guide id="1" orient="horz" pos="2160">
+          <p15:clr>
+            <a:srgbClr val="A4A3A4"/>
+          </p15:clr>
+        </p15:guide>
+        <p15:guide id="2" pos="2880">
+          <p15:clr>
+            <a:srgbClr val="A4A3A4"/>
+          </p15:clr>
+        </p15:guide>
+      </p15:sldGuideLst>
+    </p:ext>
+  </p:extLst>
 </p:presentation>
 </file>
 
@@ -162,10 +178,9 @@
           <a:lstStyle/>
           <a:p>
             <a:r>
-              <a:rPr lang="en-US" smtClean="0"/>
+              <a:rPr lang="en-US"/>
               <a:t>Click to edit Master title style</a:t>
             </a:r>
-            <a:endParaRPr lang="en-US"/>
           </a:p>
         </p:txBody>
       </p:sp>
@@ -281,10 +296,9 @@
           </a:lstStyle>
           <a:p>
             <a:r>
-              <a:rPr lang="en-US" smtClean="0"/>
+              <a:rPr lang="en-US"/>
               <a:t>Click to edit Master subtitle style</a:t>
             </a:r>
-            <a:endParaRPr lang="en-US"/>
           </a:p>
         </p:txBody>
       </p:sp>
@@ -305,7 +319,7 @@
           <a:p>
             <a:fld id="{5BCAD085-E8A6-8845-BD4E-CB4CCA059FC4}" type="datetimeFigureOut">
               <a:rPr lang="en-US" smtClean="0"/>
-              <a:t>1/27/13</a:t>
+              <a:t>7/10/2026</a:t>
             </a:fld>
             <a:endParaRPr lang="en-US"/>
           </a:p>
@@ -399,10 +413,9 @@
           <a:lstStyle/>
           <a:p>
             <a:r>
-              <a:rPr lang="en-US" smtClean="0"/>
+              <a:rPr lang="en-US"/>
               <a:t>Click to edit Master title style</a:t>
             </a:r>
-            <a:endParaRPr lang="en-US"/>
           </a:p>
         </p:txBody>
       </p:sp>
@@ -423,38 +436,37 @@
           <a:p>
             <a:pPr lvl="0"/>
             <a:r>
-              <a:rPr lang="en-US" smtClean="0"/>
+              <a:rPr lang="en-US"/>
               <a:t>Click to edit Master text styles</a:t>
             </a:r>
           </a:p>
           <a:p>
             <a:pPr lvl="1"/>
             <a:r>
-              <a:rPr lang="en-US" smtClean="0"/>
+              <a:rPr lang="en-US"/>
               <a:t>Second level</a:t>
             </a:r>
           </a:p>
           <a:p>
             <a:pPr lvl="2"/>
             <a:r>
-              <a:rPr lang="en-US" smtClean="0"/>
+              <a:rPr lang="en-US"/>
               <a:t>Third level</a:t>
             </a:r>
           </a:p>
           <a:p>
             <a:pPr lvl="3"/>
             <a:r>
-              <a:rPr lang="en-US" smtClean="0"/>
+              <a:rPr lang="en-US"/>
               <a:t>Fourth level</a:t>
             </a:r>
           </a:p>
           <a:p>
             <a:pPr lvl="4"/>
             <a:r>
-              <a:rPr lang="en-US" smtClean="0"/>
+              <a:rPr lang="en-US"/>
               <a:t>Fifth level</a:t>
             </a:r>
-            <a:endParaRPr lang="en-US"/>
           </a:p>
         </p:txBody>
       </p:sp>
@@ -475,7 +487,7 @@
           <a:p>
             <a:fld id="{5BCAD085-E8A6-8845-BD4E-CB4CCA059FC4}" type="datetimeFigureOut">
               <a:rPr lang="en-US" smtClean="0"/>
-              <a:t>1/27/13</a:t>
+              <a:t>7/10/2026</a:t>
             </a:fld>
             <a:endParaRPr lang="en-US"/>
           </a:p>
@@ -574,10 +586,9 @@
           <a:lstStyle/>
           <a:p>
             <a:r>
-              <a:rPr lang="en-US" smtClean="0"/>
+              <a:rPr lang="en-US"/>
               <a:t>Click to edit Master title style</a:t>
             </a:r>
-            <a:endParaRPr lang="en-US"/>
           </a:p>
         </p:txBody>
       </p:sp>
@@ -603,38 +614,37 @@
           <a:p>
             <a:pPr lvl="0"/>
             <a:r>
-              <a:rPr lang="en-US" smtClean="0"/>
+              <a:rPr lang="en-US"/>
               <a:t>Click to edit Master text styles</a:t>
             </a:r>
           </a:p>
           <a:p>
             <a:pPr lvl="1"/>
             <a:r>
-              <a:rPr lang="en-US" smtClean="0"/>
+              <a:rPr lang="en-US"/>
               <a:t>Second level</a:t>
             </a:r>
           </a:p>
           <a:p>
             <a:pPr lvl="2"/>
             <a:r>
-              <a:rPr lang="en-US" smtClean="0"/>
+              <a:rPr lang="en-US"/>
               <a:t>Third level</a:t>
             </a:r>
           </a:p>
           <a:p>
             <a:pPr lvl="3"/>
             <a:r>
-              <a:rPr lang="en-US" smtClean="0"/>
+              <a:rPr lang="en-US"/>
               <a:t>Fourth level</a:t>
             </a:r>
           </a:p>
           <a:p>
             <a:pPr lvl="4"/>
             <a:r>
-              <a:rPr lang="en-US" smtClean="0"/>
+              <a:rPr lang="en-US"/>
               <a:t>Fifth level</a:t>
             </a:r>
-            <a:endParaRPr lang="en-US"/>
           </a:p>
         </p:txBody>
       </p:sp>
@@ -655,7 +665,7 @@
           <a:p>
             <a:fld id="{5BCAD085-E8A6-8845-BD4E-CB4CCA059FC4}" type="datetimeFigureOut">
               <a:rPr lang="en-US" smtClean="0"/>
-              <a:t>1/27/13</a:t>
+              <a:t>7/10/2026</a:t>
             </a:fld>
             <a:endParaRPr lang="en-US"/>
           </a:p>
@@ -749,10 +759,9 @@
           <a:lstStyle/>
           <a:p>
             <a:r>
-              <a:rPr lang="en-US" smtClean="0"/>
+              <a:rPr lang="en-US"/>
               <a:t>Click to edit Master title style</a:t>
             </a:r>
-            <a:endParaRPr lang="en-US"/>
           </a:p>
         </p:txBody>
       </p:sp>
@@ -773,38 +782,37 @@
           <a:p>
             <a:pPr lvl="0"/>
             <a:r>
-              <a:rPr lang="en-US" smtClean="0"/>
+              <a:rPr lang="en-US"/>
               <a:t>Click to edit Master text styles</a:t>
             </a:r>
           </a:p>
           <a:p>
             <a:pPr lvl="1"/>
             <a:r>
-              <a:rPr lang="en-US" smtClean="0"/>
+              <a:rPr lang="en-US"/>
               <a:t>Second level</a:t>
             </a:r>
           </a:p>
           <a:p>
             <a:pPr lvl="2"/>
             <a:r>
-              <a:rPr lang="en-US" smtClean="0"/>
+              <a:rPr lang="en-US"/>
               <a:t>Third level</a:t>
             </a:r>
           </a:p>
           <a:p>
             <a:pPr lvl="3"/>
             <a:r>
-              <a:rPr lang="en-US" smtClean="0"/>
+              <a:rPr lang="en-US"/>
               <a:t>Fourth level</a:t>
             </a:r>
           </a:p>
           <a:p>
             <a:pPr lvl="4"/>
             <a:r>
-              <a:rPr lang="en-US" smtClean="0"/>
+              <a:rPr lang="en-US"/>
               <a:t>Fifth level</a:t>
             </a:r>
-            <a:endParaRPr lang="en-US"/>
           </a:p>
         </p:txBody>
       </p:sp>
@@ -825,7 +833,7 @@
           <a:p>
             <a:fld id="{5BCAD085-E8A6-8845-BD4E-CB4CCA059FC4}" type="datetimeFigureOut">
               <a:rPr lang="en-US" smtClean="0"/>
-              <a:t>1/27/13</a:t>
+              <a:t>7/10/2026</a:t>
             </a:fld>
             <a:endParaRPr lang="en-US"/>
           </a:p>
@@ -928,10 +936,9 @@
           </a:lstStyle>
           <a:p>
             <a:r>
-              <a:rPr lang="en-US" smtClean="0"/>
+              <a:rPr lang="en-US"/>
               <a:t>Click to edit Master title style</a:t>
             </a:r>
-            <a:endParaRPr lang="en-US"/>
           </a:p>
         </p:txBody>
       </p:sp>
@@ -1048,7 +1055,7 @@
           <a:p>
             <a:pPr lvl="0"/>
             <a:r>
-              <a:rPr lang="en-US" smtClean="0"/>
+              <a:rPr lang="en-US"/>
               <a:t>Click to edit Master text styles</a:t>
             </a:r>
           </a:p>
@@ -1071,7 +1078,7 @@
           <a:p>
             <a:fld id="{5BCAD085-E8A6-8845-BD4E-CB4CCA059FC4}" type="datetimeFigureOut">
               <a:rPr lang="en-US" smtClean="0"/>
-              <a:t>1/27/13</a:t>
+              <a:t>7/10/2026</a:t>
             </a:fld>
             <a:endParaRPr lang="en-US"/>
           </a:p>
@@ -1165,10 +1172,9 @@
           <a:lstStyle/>
           <a:p>
             <a:r>
-              <a:rPr lang="en-US" smtClean="0"/>
+              <a:rPr lang="en-US"/>
               <a:t>Click to edit Master title style</a:t>
             </a:r>
-            <a:endParaRPr lang="en-US"/>
           </a:p>
         </p:txBody>
       </p:sp>
@@ -1222,38 +1228,37 @@
           <a:p>
             <a:pPr lvl="0"/>
             <a:r>
-              <a:rPr lang="en-US" smtClean="0"/>
+              <a:rPr lang="en-US"/>
               <a:t>Click to edit Master text styles</a:t>
             </a:r>
           </a:p>
           <a:p>
             <a:pPr lvl="1"/>
             <a:r>
-              <a:rPr lang="en-US" smtClean="0"/>
+              <a:rPr lang="en-US"/>
               <a:t>Second level</a:t>
             </a:r>
           </a:p>
           <a:p>
             <a:pPr lvl="2"/>
             <a:r>
-              <a:rPr lang="en-US" smtClean="0"/>
+              <a:rPr lang="en-US"/>
               <a:t>Third level</a:t>
             </a:r>
           </a:p>
           <a:p>
             <a:pPr lvl="3"/>
             <a:r>
-              <a:rPr lang="en-US" smtClean="0"/>
+              <a:rPr lang="en-US"/>
               <a:t>Fourth level</a:t>
             </a:r>
           </a:p>
           <a:p>
             <a:pPr lvl="4"/>
             <a:r>
-              <a:rPr lang="en-US" smtClean="0"/>
+              <a:rPr lang="en-US"/>
               <a:t>Fifth level</a:t>
             </a:r>
-            <a:endParaRPr lang="en-US"/>
           </a:p>
         </p:txBody>
       </p:sp>
@@ -1307,38 +1312,37 @@
           <a:p>
             <a:pPr lvl="0"/>
             <a:r>
-              <a:rPr lang="en-US" smtClean="0"/>
+              <a:rPr lang="en-US"/>
               <a:t>Click to edit Master text styles</a:t>
             </a:r>
           </a:p>
           <a:p>
             <a:pPr lvl="1"/>
             <a:r>
-              <a:rPr lang="en-US" smtClean="0"/>
+              <a:rPr lang="en-US"/>
               <a:t>Second level</a:t>
             </a:r>
           </a:p>
           <a:p>
             <a:pPr lvl="2"/>
             <a:r>
-              <a:rPr lang="en-US" smtClean="0"/>
+              <a:rPr lang="en-US"/>
               <a:t>Third level</a:t>
             </a:r>
           </a:p>
           <a:p>
             <a:pPr lvl="3"/>
             <a:r>
-              <a:rPr lang="en-US" smtClean="0"/>
+              <a:rPr lang="en-US"/>
               <a:t>Fourth level</a:t>
             </a:r>
           </a:p>
           <a:p>
             <a:pPr lvl="4"/>
             <a:r>
-              <a:rPr lang="en-US" smtClean="0"/>
+              <a:rPr lang="en-US"/>
               <a:t>Fifth level</a:t>
             </a:r>
-            <a:endParaRPr lang="en-US"/>
           </a:p>
         </p:txBody>
       </p:sp>
@@ -1359,7 +1363,7 @@
           <a:p>
             <a:fld id="{5BCAD085-E8A6-8845-BD4E-CB4CCA059FC4}" type="datetimeFigureOut">
               <a:rPr lang="en-US" smtClean="0"/>
-              <a:t>1/27/13</a:t>
+              <a:t>7/10/2026</a:t>
             </a:fld>
             <a:endParaRPr lang="en-US"/>
           </a:p>
@@ -1457,10 +1461,9 @@
           </a:lstStyle>
           <a:p>
             <a:r>
-              <a:rPr lang="en-US" smtClean="0"/>
+              <a:rPr lang="en-US"/>
               <a:t>Click to edit Master title style</a:t>
             </a:r>
-            <a:endParaRPr lang="en-US"/>
           </a:p>
         </p:txBody>
       </p:sp>
@@ -1523,7 +1526,7 @@
           <a:p>
             <a:pPr lvl="0"/>
             <a:r>
-              <a:rPr lang="en-US" smtClean="0"/>
+              <a:rPr lang="en-US"/>
               <a:t>Click to edit Master text styles</a:t>
             </a:r>
           </a:p>
@@ -1579,38 +1582,37 @@
           <a:p>
             <a:pPr lvl="0"/>
             <a:r>
-              <a:rPr lang="en-US" smtClean="0"/>
+              <a:rPr lang="en-US"/>
               <a:t>Click to edit Master text styles</a:t>
             </a:r>
           </a:p>
           <a:p>
             <a:pPr lvl="1"/>
             <a:r>
-              <a:rPr lang="en-US" smtClean="0"/>
+              <a:rPr lang="en-US"/>
               <a:t>Second level</a:t>
             </a:r>
           </a:p>
           <a:p>
             <a:pPr lvl="2"/>
             <a:r>
-              <a:rPr lang="en-US" smtClean="0"/>
+              <a:rPr lang="en-US"/>
               <a:t>Third level</a:t>
             </a:r>
           </a:p>
           <a:p>
             <a:pPr lvl="3"/>
             <a:r>
-              <a:rPr lang="en-US" smtClean="0"/>
+              <a:rPr lang="en-US"/>
               <a:t>Fourth level</a:t>
             </a:r>
           </a:p>
           <a:p>
             <a:pPr lvl="4"/>
             <a:r>
-              <a:rPr lang="en-US" smtClean="0"/>
+              <a:rPr lang="en-US"/>
               <a:t>Fifth level</a:t>
             </a:r>
-            <a:endParaRPr lang="en-US"/>
           </a:p>
         </p:txBody>
       </p:sp>
@@ -1673,7 +1675,7 @@
           <a:p>
             <a:pPr lvl="0"/>
             <a:r>
-              <a:rPr lang="en-US" smtClean="0"/>
+              <a:rPr lang="en-US"/>
               <a:t>Click to edit Master text styles</a:t>
             </a:r>
           </a:p>
@@ -1729,38 +1731,37 @@
           <a:p>
             <a:pPr lvl="0"/>
             <a:r>
-              <a:rPr lang="en-US" smtClean="0"/>
+              <a:rPr lang="en-US"/>
               <a:t>Click to edit Master text styles</a:t>
             </a:r>
           </a:p>
           <a:p>
             <a:pPr lvl="1"/>
             <a:r>
-              <a:rPr lang="en-US" smtClean="0"/>
+              <a:rPr lang="en-US"/>
               <a:t>Second level</a:t>
             </a:r>
           </a:p>
           <a:p>
             <a:pPr lvl="2"/>
             <a:r>
-              <a:rPr lang="en-US" smtClean="0"/>
+              <a:rPr lang="en-US"/>
               <a:t>Third level</a:t>
             </a:r>
           </a:p>
           <a:p>
             <a:pPr lvl="3"/>
             <a:r>
-              <a:rPr lang="en-US" smtClean="0"/>
+              <a:rPr lang="en-US"/>
               <a:t>Fourth level</a:t>
             </a:r>
           </a:p>
           <a:p>
             <a:pPr lvl="4"/>
             <a:r>
-              <a:rPr lang="en-US" smtClean="0"/>
+              <a:rPr lang="en-US"/>
               <a:t>Fifth level</a:t>
             </a:r>
-            <a:endParaRPr lang="en-US"/>
           </a:p>
         </p:txBody>
       </p:sp>
@@ -1781,7 +1782,7 @@
           <a:p>
             <a:fld id="{5BCAD085-E8A6-8845-BD4E-CB4CCA059FC4}" type="datetimeFigureOut">
               <a:rPr lang="en-US" smtClean="0"/>
-              <a:t>1/27/13</a:t>
+              <a:t>7/10/2026</a:t>
             </a:fld>
             <a:endParaRPr lang="en-US"/>
           </a:p>
@@ -1875,10 +1876,9 @@
           <a:lstStyle/>
           <a:p>
             <a:r>
-              <a:rPr lang="en-US" smtClean="0"/>
+              <a:rPr lang="en-US"/>
               <a:t>Click to edit Master title style</a:t>
             </a:r>
-            <a:endParaRPr lang="en-US"/>
           </a:p>
         </p:txBody>
       </p:sp>
@@ -1899,7 +1899,7 @@
           <a:p>
             <a:fld id="{5BCAD085-E8A6-8845-BD4E-CB4CCA059FC4}" type="datetimeFigureOut">
               <a:rPr lang="en-US" smtClean="0"/>
-              <a:t>1/27/13</a:t>
+              <a:t>7/10/2026</a:t>
             </a:fld>
             <a:endParaRPr lang="en-US"/>
           </a:p>
@@ -1994,7 +1994,7 @@
           <a:p>
             <a:fld id="{5BCAD085-E8A6-8845-BD4E-CB4CCA059FC4}" type="datetimeFigureOut">
               <a:rPr lang="en-US" smtClean="0"/>
-              <a:t>1/27/13</a:t>
+              <a:t>7/10/2026</a:t>
             </a:fld>
             <a:endParaRPr lang="en-US"/>
           </a:p>
@@ -2097,10 +2097,9 @@
           </a:lstStyle>
           <a:p>
             <a:r>
-              <a:rPr lang="en-US" smtClean="0"/>
+              <a:rPr lang="en-US"/>
               <a:t>Click to edit Master title style</a:t>
             </a:r>
-            <a:endParaRPr lang="en-US"/>
           </a:p>
         </p:txBody>
       </p:sp>
@@ -2154,38 +2153,37 @@
           <a:p>
             <a:pPr lvl="0"/>
             <a:r>
-              <a:rPr lang="en-US" smtClean="0"/>
+              <a:rPr lang="en-US"/>
               <a:t>Click to edit Master text styles</a:t>
             </a:r>
           </a:p>
           <a:p>
             <a:pPr lvl="1"/>
             <a:r>
-              <a:rPr lang="en-US" smtClean="0"/>
+              <a:rPr lang="en-US"/>
               <a:t>Second level</a:t>
             </a:r>
           </a:p>
           <a:p>
             <a:pPr lvl="2"/>
             <a:r>
-              <a:rPr lang="en-US" smtClean="0"/>
+              <a:rPr lang="en-US"/>
               <a:t>Third level</a:t>
             </a:r>
           </a:p>
           <a:p>
             <a:pPr lvl="3"/>
             <a:r>
-              <a:rPr lang="en-US" smtClean="0"/>
+              <a:rPr lang="en-US"/>
               <a:t>Fourth level</a:t>
             </a:r>
           </a:p>
           <a:p>
             <a:pPr lvl="4"/>
             <a:r>
-              <a:rPr lang="en-US" smtClean="0"/>
+              <a:rPr lang="en-US"/>
               <a:t>Fifth level</a:t>
             </a:r>
-            <a:endParaRPr lang="en-US"/>
           </a:p>
         </p:txBody>
       </p:sp>
@@ -2248,7 +2246,7 @@
           <a:p>
             <a:pPr lvl="0"/>
             <a:r>
-              <a:rPr lang="en-US" smtClean="0"/>
+              <a:rPr lang="en-US"/>
               <a:t>Click to edit Master text styles</a:t>
             </a:r>
           </a:p>
@@ -2271,7 +2269,7 @@
           <a:p>
             <a:fld id="{5BCAD085-E8A6-8845-BD4E-CB4CCA059FC4}" type="datetimeFigureOut">
               <a:rPr lang="en-US" smtClean="0"/>
-              <a:t>1/27/13</a:t>
+              <a:t>7/10/2026</a:t>
             </a:fld>
             <a:endParaRPr lang="en-US"/>
           </a:p>
@@ -2374,10 +2372,9 @@
           </a:lstStyle>
           <a:p>
             <a:r>
-              <a:rPr lang="en-US" smtClean="0"/>
+              <a:rPr lang="en-US"/>
               <a:t>Click to edit Master title style</a:t>
             </a:r>
-            <a:endParaRPr lang="en-US"/>
           </a:p>
         </p:txBody>
       </p:sp>
@@ -2501,7 +2498,7 @@
           <a:p>
             <a:pPr lvl="0"/>
             <a:r>
-              <a:rPr lang="en-US" smtClean="0"/>
+              <a:rPr lang="en-US"/>
               <a:t>Click to edit Master text styles</a:t>
             </a:r>
           </a:p>
@@ -2524,7 +2521,7 @@
           <a:p>
             <a:fld id="{5BCAD085-E8A6-8845-BD4E-CB4CCA059FC4}" type="datetimeFigureOut">
               <a:rPr lang="en-US" smtClean="0"/>
-              <a:t>1/27/13</a:t>
+              <a:t>7/10/2026</a:t>
             </a:fld>
             <a:endParaRPr lang="en-US"/>
           </a:p>
@@ -2633,10 +2630,9 @@
           <a:lstStyle/>
           <a:p>
             <a:r>
-              <a:rPr lang="en-US" smtClean="0"/>
+              <a:rPr lang="en-US"/>
               <a:t>Click to edit Master title style</a:t>
             </a:r>
-            <a:endParaRPr lang="en-US"/>
           </a:p>
         </p:txBody>
       </p:sp>
@@ -2667,38 +2663,37 @@
           <a:p>
             <a:pPr lvl="0"/>
             <a:r>
-              <a:rPr lang="en-US" smtClean="0"/>
+              <a:rPr lang="en-US"/>
               <a:t>Click to edit Master text styles</a:t>
             </a:r>
           </a:p>
           <a:p>
             <a:pPr lvl="1"/>
             <a:r>
-              <a:rPr lang="en-US" smtClean="0"/>
+              <a:rPr lang="en-US"/>
               <a:t>Second level</a:t>
             </a:r>
           </a:p>
           <a:p>
             <a:pPr lvl="2"/>
             <a:r>
-              <a:rPr lang="en-US" smtClean="0"/>
+              <a:rPr lang="en-US"/>
               <a:t>Third level</a:t>
             </a:r>
           </a:p>
           <a:p>
             <a:pPr lvl="3"/>
             <a:r>
-              <a:rPr lang="en-US" smtClean="0"/>
+              <a:rPr lang="en-US"/>
               <a:t>Fourth level</a:t>
             </a:r>
           </a:p>
           <a:p>
             <a:pPr lvl="4"/>
             <a:r>
-              <a:rPr lang="en-US" smtClean="0"/>
+              <a:rPr lang="en-US"/>
               <a:t>Fifth level</a:t>
             </a:r>
-            <a:endParaRPr lang="en-US"/>
           </a:p>
         </p:txBody>
       </p:sp>
@@ -2737,7 +2732,7 @@
           <a:p>
             <a:fld id="{5BCAD085-E8A6-8845-BD4E-CB4CCA059FC4}" type="datetimeFigureOut">
               <a:rPr lang="en-US" smtClean="0"/>
-              <a:t>1/27/13</a:t>
+              <a:t>7/10/2026</a:t>
             </a:fld>
             <a:endParaRPr lang="en-US"/>
           </a:p>
@@ -3096,7 +3091,7 @@
 </file>
 
 <file path=ppt/slides/slide1.xml><?xml version="1.0" encoding="utf-8"?>
-<p:sld xmlns:a="http://schemas.openxmlformats.org/drawingml/2006/main" xmlns:p="http://schemas.openxmlformats.org/presentationml/2006/main" xmlns:r="http://schemas.openxmlformats.org/officeDocument/2006/relationships">
+<p:sld xmlns:a="http://schemas.openxmlformats.org/drawingml/2006/main" xmlns:r="http://schemas.openxmlformats.org/officeDocument/2006/relationships" xmlns:p="http://schemas.openxmlformats.org/presentationml/2006/main">
   <p:cSld>
     <p:bg>
       <p:bgPr>
@@ -3112,7 +3107,14 @@
         <p:cNvGrpSpPr/>
         <p:nvPr/>
       </p:nvGrpSpPr>
-      <p:grpSpPr/>
+      <p:grpSpPr>
+        <a:xfrm>
+          <a:off x="0" y="0"/>
+          <a:ext cx="0" cy="0"/>
+          <a:chOff x="0" y="0"/>
+          <a:chExt cx="0" cy="0"/>
+        </a:xfrm>
+      </p:grpSpPr>
       <p:sp>
         <p:nvSpPr>
           <p:cNvPr id="2" name="Rectangle 1"/>
@@ -3153,6 +3155,7 @@
           <a:lstStyle/>
           <a:p>
             <a:pPr algn="ctr"/>
+            <a:endParaRPr/>
           </a:p>
         </p:txBody>
       </p:sp>
@@ -3196,6 +3199,7 @@
           <a:lstStyle/>
           <a:p>
             <a:pPr algn="ctr"/>
+            <a:endParaRPr/>
           </a:p>
         </p:txBody>
       </p:sp>
@@ -3342,6 +3346,7 @@
           <a:lstStyle/>
           <a:p>
             <a:pPr algn="ctr"/>
+            <a:endParaRPr/>
           </a:p>
         </p:txBody>
       </p:sp>
@@ -3381,7 +3386,7 @@
           </a:fontRef>
         </p:style>
         <p:txBody>
-          <a:bodyPr rtlCol="0" anchor="ctr" wrap="none"/>
+          <a:bodyPr wrap="none" rtlCol="0" anchor="ctr"/>
           <a:lstStyle/>
           <a:p>
             <a:pPr algn="ctr"/>
@@ -3432,7 +3437,7 @@
           </a:fontRef>
         </p:style>
         <p:txBody>
-          <a:bodyPr rtlCol="0" anchor="ctr" wrap="none"/>
+          <a:bodyPr wrap="none" rtlCol="0" anchor="ctr"/>
           <a:lstStyle/>
           <a:p>
             <a:pPr algn="ctr"/>
@@ -3483,7 +3488,7 @@
           </a:fontRef>
         </p:style>
         <p:txBody>
-          <a:bodyPr rtlCol="0" anchor="ctr" wrap="none"/>
+          <a:bodyPr wrap="none" rtlCol="0" anchor="ctr"/>
           <a:lstStyle/>
           <a:p>
             <a:pPr algn="ctr"/>
@@ -3534,7 +3539,7 @@
           </a:fontRef>
         </p:style>
         <p:txBody>
-          <a:bodyPr rtlCol="0" anchor="ctr" wrap="none"/>
+          <a:bodyPr wrap="none" rtlCol="0" anchor="ctr"/>
           <a:lstStyle/>
           <a:p>
             <a:pPr algn="ctr"/>
@@ -3625,7 +3630,7 @@
         </p:nvSpPr>
         <p:spPr>
           <a:xfrm>
-            <a:off x="6858000" y="1097280"/>
+            <a:off x="6812280" y="-36575"/>
             <a:ext cx="5029200" cy="4114800"/>
           </a:xfrm>
           <a:prstGeom prst="rect">
@@ -3641,7 +3646,7 @@
           <a:p>
             <a:pPr algn="l"/>
             <a:r>
-              <a:rPr sz="20000" b="1" i="0">
+              <a:rPr sz="20000" b="1" i="0" dirty="0">
                 <a:solidFill>
                   <a:srgbClr val="112545"/>
                 </a:solidFill>
@@ -3660,7 +3665,7 @@
 </file>
 
 <file path=ppt/slides/slide10.xml><?xml version="1.0" encoding="utf-8"?>
-<p:sld xmlns:a="http://schemas.openxmlformats.org/drawingml/2006/main" xmlns:p="http://schemas.openxmlformats.org/presentationml/2006/main" xmlns:r="http://schemas.openxmlformats.org/officeDocument/2006/relationships">
+<p:sld xmlns:a="http://schemas.openxmlformats.org/drawingml/2006/main" xmlns:r="http://schemas.openxmlformats.org/officeDocument/2006/relationships" xmlns:p="http://schemas.openxmlformats.org/presentationml/2006/main">
   <p:cSld>
     <p:bg>
       <p:bgPr>
@@ -3676,7 +3681,14 @@
         <p:cNvGrpSpPr/>
         <p:nvPr/>
       </p:nvGrpSpPr>
-      <p:grpSpPr/>
+      <p:grpSpPr>
+        <a:xfrm>
+          <a:off x="0" y="0"/>
+          <a:ext cx="0" cy="0"/>
+          <a:chOff x="0" y="0"/>
+          <a:chExt cx="0" cy="0"/>
+        </a:xfrm>
+      </p:grpSpPr>
       <p:sp>
         <p:nvSpPr>
           <p:cNvPr id="2" name="Rectangle 1"/>
@@ -3717,6 +3729,7 @@
           <a:lstStyle/>
           <a:p>
             <a:pPr algn="ctr"/>
+            <a:endParaRPr/>
           </a:p>
         </p:txBody>
       </p:sp>
@@ -3830,6 +3843,7 @@
           <a:lstStyle/>
           <a:p>
             <a:pPr algn="ctr"/>
+            <a:endParaRPr/>
           </a:p>
         </p:txBody>
       </p:sp>
@@ -3873,6 +3887,7 @@
           <a:lstStyle/>
           <a:p>
             <a:pPr algn="ctr"/>
+            <a:endParaRPr/>
           </a:p>
         </p:txBody>
       </p:sp>
@@ -3987,6 +4002,7 @@
           <a:lstStyle/>
           <a:p>
             <a:pPr algn="ctr"/>
+            <a:endParaRPr/>
           </a:p>
         </p:txBody>
       </p:sp>
@@ -4030,6 +4046,7 @@
           <a:lstStyle/>
           <a:p>
             <a:pPr algn="ctr"/>
+            <a:endParaRPr/>
           </a:p>
         </p:txBody>
       </p:sp>
@@ -4110,7 +4127,7 @@
         </p:nvSpPr>
         <p:spPr>
           <a:xfrm>
-            <a:off x="8284464" y="4114800"/>
+            <a:off x="8279892" y="1828800"/>
             <a:ext cx="3657600" cy="2103120"/>
           </a:xfrm>
           <a:prstGeom prst="rect">
@@ -4144,6 +4161,7 @@
           <a:lstStyle/>
           <a:p>
             <a:pPr algn="ctr"/>
+            <a:endParaRPr/>
           </a:p>
         </p:txBody>
       </p:sp>
@@ -4155,7 +4173,7 @@
         </p:nvSpPr>
         <p:spPr>
           <a:xfrm>
-            <a:off x="8284464" y="4114800"/>
+            <a:off x="8279892" y="1828800"/>
             <a:ext cx="45720" cy="2103120"/>
           </a:xfrm>
           <a:prstGeom prst="rect">
@@ -4187,6 +4205,7 @@
           <a:lstStyle/>
           <a:p>
             <a:pPr algn="ctr"/>
+            <a:endParaRPr/>
           </a:p>
         </p:txBody>
       </p:sp>
@@ -4198,7 +4217,7 @@
         </p:nvSpPr>
         <p:spPr>
           <a:xfrm>
-            <a:off x="8394192" y="4206240"/>
+            <a:off x="8389620" y="1920240"/>
             <a:ext cx="3474720" cy="274320"/>
           </a:xfrm>
           <a:prstGeom prst="rect">
@@ -4232,7 +4251,7 @@
         </p:nvSpPr>
         <p:spPr>
           <a:xfrm>
-            <a:off x="8394192" y="4462272"/>
+            <a:off x="8389620" y="2176272"/>
             <a:ext cx="3474720" cy="1691639"/>
           </a:xfrm>
           <a:prstGeom prst="rect">
@@ -4301,6 +4320,7 @@
           <a:lstStyle/>
           <a:p>
             <a:pPr algn="ctr"/>
+            <a:endParaRPr/>
           </a:p>
         </p:txBody>
       </p:sp>
@@ -4344,6 +4364,7 @@
           <a:lstStyle/>
           <a:p>
             <a:pPr algn="ctr"/>
+            <a:endParaRPr/>
           </a:p>
         </p:txBody>
       </p:sp>
@@ -4424,7 +4445,7 @@
         </p:nvSpPr>
         <p:spPr>
           <a:xfrm>
-            <a:off x="4370832" y="6400800"/>
+            <a:off x="4366260" y="4114800"/>
             <a:ext cx="3657600" cy="2103120"/>
           </a:xfrm>
           <a:prstGeom prst="rect">
@@ -4458,6 +4479,7 @@
           <a:lstStyle/>
           <a:p>
             <a:pPr algn="ctr"/>
+            <a:endParaRPr/>
           </a:p>
         </p:txBody>
       </p:sp>
@@ -4469,7 +4491,7 @@
         </p:nvSpPr>
         <p:spPr>
           <a:xfrm>
-            <a:off x="4370832" y="6400800"/>
+            <a:off x="4366260" y="4114800"/>
             <a:ext cx="45720" cy="2103120"/>
           </a:xfrm>
           <a:prstGeom prst="rect">
@@ -4501,6 +4523,7 @@
           <a:lstStyle/>
           <a:p>
             <a:pPr algn="ctr"/>
+            <a:endParaRPr/>
           </a:p>
         </p:txBody>
       </p:sp>
@@ -4512,7 +4535,7 @@
         </p:nvSpPr>
         <p:spPr>
           <a:xfrm>
-            <a:off x="4480560" y="6492240"/>
+            <a:off x="4475988" y="4206240"/>
             <a:ext cx="3474720" cy="274320"/>
           </a:xfrm>
           <a:prstGeom prst="rect">
@@ -4546,7 +4569,7 @@
         </p:nvSpPr>
         <p:spPr>
           <a:xfrm>
-            <a:off x="4480560" y="6748272"/>
+            <a:off x="4475988" y="4462272"/>
             <a:ext cx="3474720" cy="1691639"/>
           </a:xfrm>
           <a:prstGeom prst="rect">
@@ -4581,7 +4604,7 @@
         </p:nvSpPr>
         <p:spPr>
           <a:xfrm>
-            <a:off x="8284464" y="6400800"/>
+            <a:off x="8279892" y="4114800"/>
             <a:ext cx="3657600" cy="2103120"/>
           </a:xfrm>
           <a:prstGeom prst="rect">
@@ -4615,6 +4638,7 @@
           <a:lstStyle/>
           <a:p>
             <a:pPr algn="ctr"/>
+            <a:endParaRPr/>
           </a:p>
         </p:txBody>
       </p:sp>
@@ -4626,7 +4650,7 @@
         </p:nvSpPr>
         <p:spPr>
           <a:xfrm>
-            <a:off x="8284464" y="6400800"/>
+            <a:off x="8279892" y="4114800"/>
             <a:ext cx="45720" cy="2103120"/>
           </a:xfrm>
           <a:prstGeom prst="rect">
@@ -4658,6 +4682,7 @@
           <a:lstStyle/>
           <a:p>
             <a:pPr algn="ctr"/>
+            <a:endParaRPr/>
           </a:p>
         </p:txBody>
       </p:sp>
@@ -4669,7 +4694,7 @@
         </p:nvSpPr>
         <p:spPr>
           <a:xfrm>
-            <a:off x="8394192" y="6492240"/>
+            <a:off x="8389620" y="4206240"/>
             <a:ext cx="3474720" cy="274320"/>
           </a:xfrm>
           <a:prstGeom prst="rect">
@@ -4703,7 +4728,7 @@
         </p:nvSpPr>
         <p:spPr>
           <a:xfrm>
-            <a:off x="8394192" y="6748272"/>
+            <a:off x="8389620" y="4462272"/>
             <a:ext cx="3474720" cy="1691639"/>
           </a:xfrm>
           <a:prstGeom prst="rect">
@@ -4739,7 +4764,7 @@
 </file>
 
 <file path=ppt/slides/slide11.xml><?xml version="1.0" encoding="utf-8"?>
-<p:sld xmlns:a="http://schemas.openxmlformats.org/drawingml/2006/main" xmlns:p="http://schemas.openxmlformats.org/presentationml/2006/main" xmlns:r="http://schemas.openxmlformats.org/officeDocument/2006/relationships">
+<p:sld xmlns:a="http://schemas.openxmlformats.org/drawingml/2006/main" xmlns:r="http://schemas.openxmlformats.org/officeDocument/2006/relationships" xmlns:p="http://schemas.openxmlformats.org/presentationml/2006/main">
   <p:cSld>
     <p:bg>
       <p:bgPr>
@@ -4755,7 +4780,14 @@
         <p:cNvGrpSpPr/>
         <p:nvPr/>
       </p:nvGrpSpPr>
-      <p:grpSpPr/>
+      <p:grpSpPr>
+        <a:xfrm>
+          <a:off x="0" y="0"/>
+          <a:ext cx="0" cy="0"/>
+          <a:chOff x="0" y="0"/>
+          <a:chExt cx="0" cy="0"/>
+        </a:xfrm>
+      </p:grpSpPr>
       <p:sp>
         <p:nvSpPr>
           <p:cNvPr id="2" name="TextBox 1"/>
@@ -4830,7 +4862,13 @@
           <p:cNvGraphicFramePr>
             <a:graphicFrameLocks noGrp="1"/>
           </p:cNvGraphicFramePr>
-          <p:nvPr/>
+          <p:nvPr>
+            <p:extLst>
+              <p:ext uri="{D42A27DB-BD31-4B8C-83A1-F6EECF244321}">
+                <p14:modId xmlns:p14="http://schemas.microsoft.com/office/powerpoint/2010/main" val="4202419578"/>
+              </p:ext>
+            </p:extLst>
+          </p:nvPr>
         </p:nvGraphicFramePr>
         <p:xfrm>
           <a:off x="457200" y="1371600"/>
@@ -4843,9 +4881,27 @@
                 <a:tableStyleId>{5C22544A-7EE6-4342-B048-85BDC9FD1C3A}</a:tableStyleId>
               </a:tblPr>
               <a:tblGrid>
-                <a:gridCol w="5029200"/>
-                <a:gridCol w="3291840"/>
-                <a:gridCol w="2926080"/>
+                <a:gridCol w="5029200">
+                  <a:extLst>
+                    <a:ext uri="{9D8B030D-6E8A-4147-A177-3AD203B41FA5}">
+                      <a16:colId xmlns:a16="http://schemas.microsoft.com/office/drawing/2014/main" val="20000"/>
+                    </a:ext>
+                  </a:extLst>
+                </a:gridCol>
+                <a:gridCol w="3291840">
+                  <a:extLst>
+                    <a:ext uri="{9D8B030D-6E8A-4147-A177-3AD203B41FA5}">
+                      <a16:colId xmlns:a16="http://schemas.microsoft.com/office/drawing/2014/main" val="20001"/>
+                    </a:ext>
+                  </a:extLst>
+                </a:gridCol>
+                <a:gridCol w="2926080">
+                  <a:extLst>
+                    <a:ext uri="{9D8B030D-6E8A-4147-A177-3AD203B41FA5}">
+                      <a16:colId xmlns:a16="http://schemas.microsoft.com/office/drawing/2014/main" val="20002"/>
+                    </a:ext>
+                  </a:extLst>
+                </a:gridCol>
               </a:tblGrid>
               <a:tr h="419100">
                 <a:tc>
@@ -4914,6 +4970,11 @@
                     </a:solidFill>
                   </a:tcPr>
                 </a:tc>
+                <a:extLst>
+                  <a:ext uri="{0D108BD9-81ED-4DB2-BD59-A6C34878D82A}">
+                    <a16:rowId xmlns:a16="http://schemas.microsoft.com/office/drawing/2014/main" val="10000"/>
+                  </a:ext>
+                </a:extLst>
               </a:tr>
               <a:tr h="419100">
                 <a:tc>
@@ -4943,14 +5004,30 @@
                     <a:bodyPr/>
                     <a:lstStyle/>
                     <a:p>
-                      <a:pPr algn="ctr"/>
+                      <a:pPr algn="l"/>
                       <a:r>
-                        <a:rPr sz="1000" b="0">
+                        <a:rPr sz="1000" b="0" dirty="0">
                           <a:solidFill>
                             <a:srgbClr val="1E293B"/>
                           </a:solidFill>
                         </a:rPr>
-                        <a:t>✅ ReactFlow v12</a:t>
+                        <a:t>✅ </a:t>
+                      </a:r>
+                      <a:r>
+                        <a:rPr sz="1000" b="0" dirty="0" err="1">
+                          <a:solidFill>
+                            <a:srgbClr val="1E293B"/>
+                          </a:solidFill>
+                        </a:rPr>
+                        <a:t>ReactFlow</a:t>
+                      </a:r>
+                      <a:r>
+                        <a:rPr sz="1000" b="0" dirty="0">
+                          <a:solidFill>
+                            <a:srgbClr val="1E293B"/>
+                          </a:solidFill>
+                        </a:rPr>
+                        <a:t> v12</a:t>
                       </a:r>
                     </a:p>
                   </a:txBody>
@@ -4982,6 +5059,11 @@
                     </a:solidFill>
                   </a:tcPr>
                 </a:tc>
+                <a:extLst>
+                  <a:ext uri="{0D108BD9-81ED-4DB2-BD59-A6C34878D82A}">
+                    <a16:rowId xmlns:a16="http://schemas.microsoft.com/office/drawing/2014/main" val="10001"/>
+                  </a:ext>
+                </a:extLst>
               </a:tr>
               <a:tr h="419100">
                 <a:tc>
@@ -5011,7 +5093,7 @@
                     <a:bodyPr/>
                     <a:lstStyle/>
                     <a:p>
-                      <a:pPr algn="ctr"/>
+                      <a:pPr algn="l"/>
                       <a:r>
                         <a:rPr sz="1000" b="0">
                           <a:solidFill>
@@ -5050,6 +5132,11 @@
                     </a:solidFill>
                   </a:tcPr>
                 </a:tc>
+                <a:extLst>
+                  <a:ext uri="{0D108BD9-81ED-4DB2-BD59-A6C34878D82A}">
+                    <a16:rowId xmlns:a16="http://schemas.microsoft.com/office/drawing/2014/main" val="10002"/>
+                  </a:ext>
+                </a:extLst>
               </a:tr>
               <a:tr h="419100">
                 <a:tc>
@@ -5079,7 +5166,7 @@
                     <a:bodyPr/>
                     <a:lstStyle/>
                     <a:p>
-                      <a:pPr algn="ctr"/>
+                      <a:pPr algn="l"/>
                       <a:r>
                         <a:rPr sz="1000" b="0">
                           <a:solidFill>
@@ -5118,6 +5205,11 @@
                     </a:solidFill>
                   </a:tcPr>
                 </a:tc>
+                <a:extLst>
+                  <a:ext uri="{0D108BD9-81ED-4DB2-BD59-A6C34878D82A}">
+                    <a16:rowId xmlns:a16="http://schemas.microsoft.com/office/drawing/2014/main" val="10003"/>
+                  </a:ext>
+                </a:extLst>
               </a:tr>
               <a:tr h="419100">
                 <a:tc>
@@ -5147,15 +5239,28 @@
                     <a:bodyPr/>
                     <a:lstStyle/>
                     <a:p>
-                      <a:pPr algn="ctr"/>
+                      <a:pPr algn="l"/>
                       <a:r>
-                        <a:rPr sz="1000" b="0">
+                        <a:rPr sz="1000" b="0" dirty="0">
                           <a:solidFill>
                             <a:srgbClr val="1E293B"/>
                           </a:solidFill>
                         </a:rPr>
-                        <a:t>✅ LangChain+pgvector</a:t>
+                        <a:t>✅ </a:t>
                       </a:r>
+                      <a:r>
+                        <a:rPr sz="1000" b="0" dirty="0" err="1">
+                          <a:solidFill>
+                            <a:srgbClr val="1E293B"/>
+                          </a:solidFill>
+                        </a:rPr>
+                        <a:t>LangChain+pgvector</a:t>
+                      </a:r>
+                      <a:endParaRPr sz="1000" b="0" dirty="0">
+                        <a:solidFill>
+                          <a:srgbClr val="1E293B"/>
+                        </a:solidFill>
+                      </a:endParaRPr>
                     </a:p>
                   </a:txBody>
                   <a:tcPr>
@@ -5186,6 +5291,11 @@
                     </a:solidFill>
                   </a:tcPr>
                 </a:tc>
+                <a:extLst>
+                  <a:ext uri="{0D108BD9-81ED-4DB2-BD59-A6C34878D82A}">
+                    <a16:rowId xmlns:a16="http://schemas.microsoft.com/office/drawing/2014/main" val="10004"/>
+                  </a:ext>
+                </a:extLst>
               </a:tr>
               <a:tr h="419100">
                 <a:tc>
@@ -5215,7 +5325,7 @@
                     <a:bodyPr/>
                     <a:lstStyle/>
                     <a:p>
-                      <a:pPr algn="ctr"/>
+                      <a:pPr algn="l"/>
                       <a:r>
                         <a:rPr sz="1000" b="0">
                           <a:solidFill>
@@ -5254,6 +5364,11 @@
                     </a:solidFill>
                   </a:tcPr>
                 </a:tc>
+                <a:extLst>
+                  <a:ext uri="{0D108BD9-81ED-4DB2-BD59-A6C34878D82A}">
+                    <a16:rowId xmlns:a16="http://schemas.microsoft.com/office/drawing/2014/main" val="10005"/>
+                  </a:ext>
+                </a:extLst>
               </a:tr>
               <a:tr h="419100">
                 <a:tc>
@@ -5283,7 +5398,7 @@
                     <a:bodyPr/>
                     <a:lstStyle/>
                     <a:p>
-                      <a:pPr algn="ctr"/>
+                      <a:pPr algn="l"/>
                       <a:r>
                         <a:rPr sz="1000" b="0">
                           <a:solidFill>
@@ -5322,6 +5437,11 @@
                     </a:solidFill>
                   </a:tcPr>
                 </a:tc>
+                <a:extLst>
+                  <a:ext uri="{0D108BD9-81ED-4DB2-BD59-A6C34878D82A}">
+                    <a16:rowId xmlns:a16="http://schemas.microsoft.com/office/drawing/2014/main" val="10006"/>
+                  </a:ext>
+                </a:extLst>
               </a:tr>
               <a:tr h="419100">
                 <a:tc>
@@ -5351,15 +5471,28 @@
                     <a:bodyPr/>
                     <a:lstStyle/>
                     <a:p>
-                      <a:pPr algn="ctr"/>
+                      <a:pPr algn="l"/>
                       <a:r>
-                        <a:rPr sz="1000" b="0">
+                        <a:rPr sz="1000" b="0" dirty="0">
                           <a:solidFill>
                             <a:srgbClr val="1E293B"/>
                           </a:solidFill>
                         </a:rPr>
-                        <a:t>✅ Full FastAPI</a:t>
+                        <a:t>✅ Full </a:t>
                       </a:r>
+                      <a:r>
+                        <a:rPr sz="1000" b="0" dirty="0" err="1">
+                          <a:solidFill>
+                            <a:srgbClr val="1E293B"/>
+                          </a:solidFill>
+                        </a:rPr>
+                        <a:t>FastAPI</a:t>
+                      </a:r>
+                      <a:endParaRPr sz="1000" b="0" dirty="0">
+                        <a:solidFill>
+                          <a:srgbClr val="1E293B"/>
+                        </a:solidFill>
+                      </a:endParaRPr>
                     </a:p>
                   </a:txBody>
                   <a:tcPr>
@@ -5390,6 +5523,11 @@
                     </a:solidFill>
                   </a:tcPr>
                 </a:tc>
+                <a:extLst>
+                  <a:ext uri="{0D108BD9-81ED-4DB2-BD59-A6C34878D82A}">
+                    <a16:rowId xmlns:a16="http://schemas.microsoft.com/office/drawing/2014/main" val="10007"/>
+                  </a:ext>
+                </a:extLst>
               </a:tr>
               <a:tr h="419100">
                 <a:tc>
@@ -5419,7 +5557,7 @@
                     <a:bodyPr/>
                     <a:lstStyle/>
                     <a:p>
-                      <a:pPr algn="ctr"/>
+                      <a:pPr algn="l"/>
                       <a:r>
                         <a:rPr sz="1000" b="0">
                           <a:solidFill>
@@ -5458,6 +5596,11 @@
                     </a:solidFill>
                   </a:tcPr>
                 </a:tc>
+                <a:extLst>
+                  <a:ext uri="{0D108BD9-81ED-4DB2-BD59-A6C34878D82A}">
+                    <a16:rowId xmlns:a16="http://schemas.microsoft.com/office/drawing/2014/main" val="10008"/>
+                  </a:ext>
+                </a:extLst>
               </a:tr>
               <a:tr h="419100">
                 <a:tc>
@@ -5487,9 +5630,9 @@
                     <a:bodyPr/>
                     <a:lstStyle/>
                     <a:p>
-                      <a:pPr algn="ctr"/>
+                      <a:pPr algn="l"/>
                       <a:r>
-                        <a:rPr sz="1000" b="0">
+                        <a:rPr sz="1000" b="0" dirty="0">
                           <a:solidFill>
                             <a:srgbClr val="1E293B"/>
                           </a:solidFill>
@@ -5526,6 +5669,11 @@
                     </a:solidFill>
                   </a:tcPr>
                 </a:tc>
+                <a:extLst>
+                  <a:ext uri="{0D108BD9-81ED-4DB2-BD59-A6C34878D82A}">
+                    <a16:rowId xmlns:a16="http://schemas.microsoft.com/office/drawing/2014/main" val="10009"/>
+                  </a:ext>
+                </a:extLst>
               </a:tr>
               <a:tr h="419100">
                 <a:tc>
@@ -5555,9 +5703,9 @@
                     <a:bodyPr/>
                     <a:lstStyle/>
                     <a:p>
-                      <a:pPr algn="ctr"/>
+                      <a:pPr algn="l"/>
                       <a:r>
-                        <a:rPr sz="1000" b="0">
+                        <a:rPr sz="1000" b="0" dirty="0">
                           <a:solidFill>
                             <a:srgbClr val="1E293B"/>
                           </a:solidFill>
@@ -5594,6 +5742,11 @@
                     </a:solidFill>
                   </a:tcPr>
                 </a:tc>
+                <a:extLst>
+                  <a:ext uri="{0D108BD9-81ED-4DB2-BD59-A6C34878D82A}">
+                    <a16:rowId xmlns:a16="http://schemas.microsoft.com/office/drawing/2014/main" val="10010"/>
+                  </a:ext>
+                </a:extLst>
               </a:tr>
               <a:tr h="419100">
                 <a:tc>
@@ -5623,9 +5776,9 @@
                     <a:bodyPr/>
                     <a:lstStyle/>
                     <a:p>
-                      <a:pPr algn="ctr"/>
+                      <a:pPr algn="l"/>
                       <a:r>
-                        <a:rPr sz="1000" b="0">
+                        <a:rPr sz="1000" b="0" dirty="0">
                           <a:solidFill>
                             <a:srgbClr val="1E293B"/>
                           </a:solidFill>
@@ -5647,7 +5800,7 @@
                     <a:p>
                       <a:pPr algn="ctr"/>
                       <a:r>
-                        <a:rPr sz="1000" b="1">
+                        <a:rPr sz="1000" b="1" dirty="0">
                           <a:solidFill>
                             <a:srgbClr val="DC2626"/>
                           </a:solidFill>
@@ -5662,6 +5815,11 @@
                     </a:solidFill>
                   </a:tcPr>
                 </a:tc>
+                <a:extLst>
+                  <a:ext uri="{0D108BD9-81ED-4DB2-BD59-A6C34878D82A}">
+                    <a16:rowId xmlns:a16="http://schemas.microsoft.com/office/drawing/2014/main" val="10011"/>
+                  </a:ext>
+                </a:extLst>
               </a:tr>
             </a:tbl>
           </a:graphicData>
@@ -5676,7 +5834,7 @@
 </file>
 
 <file path=ppt/slides/slide12.xml><?xml version="1.0" encoding="utf-8"?>
-<p:sld xmlns:a="http://schemas.openxmlformats.org/drawingml/2006/main" xmlns:p="http://schemas.openxmlformats.org/presentationml/2006/main" xmlns:r="http://schemas.openxmlformats.org/officeDocument/2006/relationships">
+<p:sld xmlns:a="http://schemas.openxmlformats.org/drawingml/2006/main" xmlns:r="http://schemas.openxmlformats.org/officeDocument/2006/relationships" xmlns:p="http://schemas.openxmlformats.org/presentationml/2006/main">
   <p:cSld>
     <p:bg>
       <p:bgPr>
@@ -5692,7 +5850,14 @@
         <p:cNvGrpSpPr/>
         <p:nvPr/>
       </p:nvGrpSpPr>
-      <p:grpSpPr/>
+      <p:grpSpPr>
+        <a:xfrm>
+          <a:off x="0" y="0"/>
+          <a:ext cx="0" cy="0"/>
+          <a:chOff x="0" y="0"/>
+          <a:chExt cx="0" cy="0"/>
+        </a:xfrm>
+      </p:grpSpPr>
       <p:sp>
         <p:nvSpPr>
           <p:cNvPr id="2" name="TextBox 1"/>
@@ -5780,13 +5945,55 @@
                 <a:tableStyleId>{5C22544A-7EE6-4342-B048-85BDC9FD1C3A}</a:tableStyleId>
               </a:tblPr>
               <a:tblGrid>
-                <a:gridCol w="2560320"/>
-                <a:gridCol w="1463040"/>
-                <a:gridCol w="1280160"/>
-                <a:gridCol w="1371600"/>
-                <a:gridCol w="1554480"/>
-                <a:gridCol w="1371600"/>
-                <a:gridCol w="1673352"/>
+                <a:gridCol w="2560320">
+                  <a:extLst>
+                    <a:ext uri="{9D8B030D-6E8A-4147-A177-3AD203B41FA5}">
+                      <a16:colId xmlns:a16="http://schemas.microsoft.com/office/drawing/2014/main" val="20000"/>
+                    </a:ext>
+                  </a:extLst>
+                </a:gridCol>
+                <a:gridCol w="1463040">
+                  <a:extLst>
+                    <a:ext uri="{9D8B030D-6E8A-4147-A177-3AD203B41FA5}">
+                      <a16:colId xmlns:a16="http://schemas.microsoft.com/office/drawing/2014/main" val="20001"/>
+                    </a:ext>
+                  </a:extLst>
+                </a:gridCol>
+                <a:gridCol w="1280160">
+                  <a:extLst>
+                    <a:ext uri="{9D8B030D-6E8A-4147-A177-3AD203B41FA5}">
+                      <a16:colId xmlns:a16="http://schemas.microsoft.com/office/drawing/2014/main" val="20002"/>
+                    </a:ext>
+                  </a:extLst>
+                </a:gridCol>
+                <a:gridCol w="1371600">
+                  <a:extLst>
+                    <a:ext uri="{9D8B030D-6E8A-4147-A177-3AD203B41FA5}">
+                      <a16:colId xmlns:a16="http://schemas.microsoft.com/office/drawing/2014/main" val="20003"/>
+                    </a:ext>
+                  </a:extLst>
+                </a:gridCol>
+                <a:gridCol w="1554480">
+                  <a:extLst>
+                    <a:ext uri="{9D8B030D-6E8A-4147-A177-3AD203B41FA5}">
+                      <a16:colId xmlns:a16="http://schemas.microsoft.com/office/drawing/2014/main" val="20004"/>
+                    </a:ext>
+                  </a:extLst>
+                </a:gridCol>
+                <a:gridCol w="1371600">
+                  <a:extLst>
+                    <a:ext uri="{9D8B030D-6E8A-4147-A177-3AD203B41FA5}">
+                      <a16:colId xmlns:a16="http://schemas.microsoft.com/office/drawing/2014/main" val="20005"/>
+                    </a:ext>
+                  </a:extLst>
+                </a:gridCol>
+                <a:gridCol w="1673352">
+                  <a:extLst>
+                    <a:ext uri="{9D8B030D-6E8A-4147-A177-3AD203B41FA5}">
+                      <a16:colId xmlns:a16="http://schemas.microsoft.com/office/drawing/2014/main" val="20006"/>
+                    </a:ext>
+                  </a:extLst>
+                </a:gridCol>
               </a:tblGrid>
               <a:tr h="548640">
                 <a:tc>
@@ -5943,6 +6150,11 @@
                     </a:solidFill>
                   </a:tcPr>
                 </a:tc>
+                <a:extLst>
+                  <a:ext uri="{0D108BD9-81ED-4DB2-BD59-A6C34878D82A}">
+                    <a16:rowId xmlns:a16="http://schemas.microsoft.com/office/drawing/2014/main" val="10000"/>
+                  </a:ext>
+                </a:extLst>
               </a:tr>
               <a:tr h="548640">
                 <a:tc>
@@ -6099,6 +6311,11 @@
                     </a:solidFill>
                   </a:tcPr>
                 </a:tc>
+                <a:extLst>
+                  <a:ext uri="{0D108BD9-81ED-4DB2-BD59-A6C34878D82A}">
+                    <a16:rowId xmlns:a16="http://schemas.microsoft.com/office/drawing/2014/main" val="10001"/>
+                  </a:ext>
+                </a:extLst>
               </a:tr>
               <a:tr h="548640">
                 <a:tc>
@@ -6255,6 +6472,11 @@
                     </a:solidFill>
                   </a:tcPr>
                 </a:tc>
+                <a:extLst>
+                  <a:ext uri="{0D108BD9-81ED-4DB2-BD59-A6C34878D82A}">
+                    <a16:rowId xmlns:a16="http://schemas.microsoft.com/office/drawing/2014/main" val="10002"/>
+                  </a:ext>
+                </a:extLst>
               </a:tr>
               <a:tr h="548640">
                 <a:tc>
@@ -6411,6 +6633,11 @@
                     </a:solidFill>
                   </a:tcPr>
                 </a:tc>
+                <a:extLst>
+                  <a:ext uri="{0D108BD9-81ED-4DB2-BD59-A6C34878D82A}">
+                    <a16:rowId xmlns:a16="http://schemas.microsoft.com/office/drawing/2014/main" val="10003"/>
+                  </a:ext>
+                </a:extLst>
               </a:tr>
               <a:tr h="548640">
                 <a:tc>
@@ -6567,6 +6794,11 @@
                     </a:solidFill>
                   </a:tcPr>
                 </a:tc>
+                <a:extLst>
+                  <a:ext uri="{0D108BD9-81ED-4DB2-BD59-A6C34878D82A}">
+                    <a16:rowId xmlns:a16="http://schemas.microsoft.com/office/drawing/2014/main" val="10004"/>
+                  </a:ext>
+                </a:extLst>
               </a:tr>
               <a:tr h="548640">
                 <a:tc>
@@ -6723,6 +6955,11 @@
                     </a:solidFill>
                   </a:tcPr>
                 </a:tc>
+                <a:extLst>
+                  <a:ext uri="{0D108BD9-81ED-4DB2-BD59-A6C34878D82A}">
+                    <a16:rowId xmlns:a16="http://schemas.microsoft.com/office/drawing/2014/main" val="10005"/>
+                  </a:ext>
+                </a:extLst>
               </a:tr>
               <a:tr h="548640">
                 <a:tc>
@@ -6879,6 +7116,11 @@
                     </a:solidFill>
                   </a:tcPr>
                 </a:tc>
+                <a:extLst>
+                  <a:ext uri="{0D108BD9-81ED-4DB2-BD59-A6C34878D82A}">
+                    <a16:rowId xmlns:a16="http://schemas.microsoft.com/office/drawing/2014/main" val="10006"/>
+                  </a:ext>
+                </a:extLst>
               </a:tr>
               <a:tr h="548640">
                 <a:tc>
@@ -7035,6 +7277,11 @@
                     </a:solidFill>
                   </a:tcPr>
                 </a:tc>
+                <a:extLst>
+                  <a:ext uri="{0D108BD9-81ED-4DB2-BD59-A6C34878D82A}">
+                    <a16:rowId xmlns:a16="http://schemas.microsoft.com/office/drawing/2014/main" val="10007"/>
+                  </a:ext>
+                </a:extLst>
               </a:tr>
               <a:tr h="548640">
                 <a:tc>
@@ -7191,6 +7438,11 @@
                     </a:solidFill>
                   </a:tcPr>
                 </a:tc>
+                <a:extLst>
+                  <a:ext uri="{0D108BD9-81ED-4DB2-BD59-A6C34878D82A}">
+                    <a16:rowId xmlns:a16="http://schemas.microsoft.com/office/drawing/2014/main" val="10008"/>
+                  </a:ext>
+                </a:extLst>
               </a:tr>
             </a:tbl>
           </a:graphicData>
@@ -7238,6 +7490,7 @@
           <a:lstStyle/>
           <a:p>
             <a:pPr algn="ctr"/>
+            <a:endParaRPr/>
           </a:p>
         </p:txBody>
       </p:sp>
@@ -7284,7 +7537,7 @@
 </file>
 
 <file path=ppt/slides/slide13.xml><?xml version="1.0" encoding="utf-8"?>
-<p:sld xmlns:a="http://schemas.openxmlformats.org/drawingml/2006/main" xmlns:p="http://schemas.openxmlformats.org/presentationml/2006/main" xmlns:r="http://schemas.openxmlformats.org/officeDocument/2006/relationships">
+<p:sld xmlns:a="http://schemas.openxmlformats.org/drawingml/2006/main" xmlns:r="http://schemas.openxmlformats.org/officeDocument/2006/relationships" xmlns:p="http://schemas.openxmlformats.org/presentationml/2006/main">
   <p:cSld>
     <p:bg>
       <p:bgPr>
@@ -7300,7 +7553,14 @@
         <p:cNvGrpSpPr/>
         <p:nvPr/>
       </p:nvGrpSpPr>
-      <p:grpSpPr/>
+      <p:grpSpPr>
+        <a:xfrm>
+          <a:off x="0" y="0"/>
+          <a:ext cx="0" cy="0"/>
+          <a:chOff x="0" y="0"/>
+          <a:chExt cx="0" cy="0"/>
+        </a:xfrm>
+      </p:grpSpPr>
       <p:sp>
         <p:nvSpPr>
           <p:cNvPr id="2" name="Rectangle 1"/>
@@ -7341,6 +7601,7 @@
           <a:lstStyle/>
           <a:p>
             <a:pPr algn="ctr"/>
+            <a:endParaRPr/>
           </a:p>
         </p:txBody>
       </p:sp>
@@ -7454,6 +7715,7 @@
           <a:lstStyle/>
           <a:p>
             <a:pPr algn="ctr"/>
+            <a:endParaRPr/>
           </a:p>
         </p:txBody>
       </p:sp>
@@ -7567,6 +7829,7 @@
           <a:lstStyle/>
           <a:p>
             <a:pPr algn="ctr"/>
+            <a:endParaRPr/>
           </a:p>
         </p:txBody>
       </p:sp>
@@ -7680,6 +7943,7 @@
           <a:lstStyle/>
           <a:p>
             <a:pPr algn="ctr"/>
+            <a:endParaRPr/>
           </a:p>
         </p:txBody>
       </p:sp>
@@ -7793,6 +8057,7 @@
           <a:lstStyle/>
           <a:p>
             <a:pPr algn="ctr"/>
+            <a:endParaRPr/>
           </a:p>
         </p:txBody>
       </p:sp>
@@ -7906,6 +8171,7 @@
           <a:lstStyle/>
           <a:p>
             <a:pPr algn="ctr"/>
+            <a:endParaRPr/>
           </a:p>
         </p:txBody>
       </p:sp>
@@ -8189,6 +8455,7 @@
           <a:lstStyle/>
           <a:p>
             <a:pPr algn="ctr"/>
+            <a:endParaRPr/>
           </a:p>
         </p:txBody>
       </p:sp>
@@ -8439,7 +8706,7 @@
 </file>
 
 <file path=ppt/slides/slide14.xml><?xml version="1.0" encoding="utf-8"?>
-<p:sld xmlns:a="http://schemas.openxmlformats.org/drawingml/2006/main" xmlns:p="http://schemas.openxmlformats.org/presentationml/2006/main" xmlns:r="http://schemas.openxmlformats.org/officeDocument/2006/relationships">
+<p:sld xmlns:a="http://schemas.openxmlformats.org/drawingml/2006/main" xmlns:r="http://schemas.openxmlformats.org/officeDocument/2006/relationships" xmlns:p="http://schemas.openxmlformats.org/presentationml/2006/main">
   <p:cSld>
     <p:bg>
       <p:bgPr>
@@ -8455,7 +8722,14 @@
         <p:cNvGrpSpPr/>
         <p:nvPr/>
       </p:nvGrpSpPr>
-      <p:grpSpPr/>
+      <p:grpSpPr>
+        <a:xfrm>
+          <a:off x="0" y="0"/>
+          <a:ext cx="0" cy="0"/>
+          <a:chOff x="0" y="0"/>
+          <a:chExt cx="0" cy="0"/>
+        </a:xfrm>
+      </p:grpSpPr>
       <p:sp>
         <p:nvSpPr>
           <p:cNvPr id="2" name="Rectangle 1"/>
@@ -8496,6 +8770,7 @@
           <a:lstStyle/>
           <a:p>
             <a:pPr algn="ctr"/>
+            <a:endParaRPr/>
           </a:p>
         </p:txBody>
       </p:sp>
@@ -8539,6 +8814,7 @@
           <a:lstStyle/>
           <a:p>
             <a:pPr algn="ctr"/>
+            <a:endParaRPr/>
           </a:p>
         </p:txBody>
       </p:sp>
@@ -8652,6 +8928,7 @@
           <a:lstStyle/>
           <a:p>
             <a:pPr algn="ctr"/>
+            <a:endParaRPr/>
           </a:p>
         </p:txBody>
       </p:sp>
@@ -8731,6 +9008,7 @@
           <a:lstStyle/>
           <a:p>
             <a:pPr algn="ctr"/>
+            <a:endParaRPr/>
           </a:p>
         </p:txBody>
       </p:sp>
@@ -8845,6 +9123,7 @@
           <a:lstStyle/>
           <a:p>
             <a:pPr algn="ctr"/>
+            <a:endParaRPr/>
           </a:p>
         </p:txBody>
       </p:sp>
@@ -8961,6 +9240,7 @@
           <a:lstStyle/>
           <a:p>
             <a:pPr algn="ctr"/>
+            <a:endParaRPr/>
           </a:p>
         </p:txBody>
       </p:sp>
@@ -9078,6 +9358,7 @@
           <a:lstStyle/>
           <a:p>
             <a:pPr algn="ctr"/>
+            <a:endParaRPr/>
           </a:p>
         </p:txBody>
       </p:sp>
@@ -9191,6 +9472,7 @@
           <a:lstStyle/>
           <a:p>
             <a:pPr algn="ctr"/>
+            <a:endParaRPr/>
           </a:p>
         </p:txBody>
       </p:sp>
@@ -9306,6 +9588,7 @@
           <a:lstStyle/>
           <a:p>
             <a:pPr algn="ctr"/>
+            <a:endParaRPr/>
           </a:p>
         </p:txBody>
       </p:sp>
@@ -9422,6 +9705,7 @@
           <a:lstStyle/>
           <a:p>
             <a:pPr algn="ctr"/>
+            <a:endParaRPr/>
           </a:p>
         </p:txBody>
       </p:sp>
@@ -9537,6 +9821,7 @@
           <a:lstStyle/>
           <a:p>
             <a:pPr algn="ctr"/>
+            <a:endParaRPr/>
           </a:p>
         </p:txBody>
       </p:sp>
@@ -9619,7 +9904,7 @@
 </file>
 
 <file path=ppt/slides/slide15.xml><?xml version="1.0" encoding="utf-8"?>
-<p:sld xmlns:a="http://schemas.openxmlformats.org/drawingml/2006/main" xmlns:p="http://schemas.openxmlformats.org/presentationml/2006/main" xmlns:r="http://schemas.openxmlformats.org/officeDocument/2006/relationships">
+<p:sld xmlns:a="http://schemas.openxmlformats.org/drawingml/2006/main" xmlns:r="http://schemas.openxmlformats.org/officeDocument/2006/relationships" xmlns:p="http://schemas.openxmlformats.org/presentationml/2006/main">
   <p:cSld>
     <p:bg>
       <p:bgPr>
@@ -9635,7 +9920,14 @@
         <p:cNvGrpSpPr/>
         <p:nvPr/>
       </p:nvGrpSpPr>
-      <p:grpSpPr/>
+      <p:grpSpPr>
+        <a:xfrm>
+          <a:off x="0" y="0"/>
+          <a:ext cx="0" cy="0"/>
+          <a:chOff x="0" y="0"/>
+          <a:chExt cx="0" cy="0"/>
+        </a:xfrm>
+      </p:grpSpPr>
       <p:sp>
         <p:nvSpPr>
           <p:cNvPr id="2" name="Rectangle 1"/>
@@ -9676,6 +9968,7 @@
           <a:lstStyle/>
           <a:p>
             <a:pPr algn="ctr"/>
+            <a:endParaRPr/>
           </a:p>
         </p:txBody>
       </p:sp>
@@ -9719,6 +10012,7 @@
           <a:lstStyle/>
           <a:p>
             <a:pPr algn="ctr"/>
+            <a:endParaRPr/>
           </a:p>
         </p:txBody>
       </p:sp>
@@ -9866,6 +10160,7 @@
           <a:lstStyle/>
           <a:p>
             <a:pPr algn="ctr"/>
+            <a:endParaRPr/>
           </a:p>
         </p:txBody>
       </p:sp>
@@ -9943,6 +10238,7 @@
           <a:lstStyle/>
           <a:p>
             <a:pPr algn="ctr"/>
+            <a:endParaRPr/>
           </a:p>
         </p:txBody>
       </p:sp>
@@ -10054,6 +10350,7 @@
           <a:lstStyle/>
           <a:p>
             <a:pPr algn="ctr"/>
+            <a:endParaRPr/>
           </a:p>
         </p:txBody>
       </p:sp>
@@ -10165,6 +10462,7 @@
           <a:lstStyle/>
           <a:p>
             <a:pPr algn="ctr"/>
+            <a:endParaRPr/>
           </a:p>
         </p:txBody>
       </p:sp>
@@ -10276,6 +10574,7 @@
           <a:lstStyle/>
           <a:p>
             <a:pPr algn="ctr"/>
+            <a:endParaRPr/>
           </a:p>
         </p:txBody>
       </p:sp>
@@ -10387,6 +10686,7 @@
           <a:lstStyle/>
           <a:p>
             <a:pPr algn="ctr"/>
+            <a:endParaRPr/>
           </a:p>
         </p:txBody>
       </p:sp>
@@ -10498,6 +10798,7 @@
           <a:lstStyle/>
           <a:p>
             <a:pPr algn="ctr"/>
+            <a:endParaRPr/>
           </a:p>
         </p:txBody>
       </p:sp>
@@ -10611,6 +10912,7 @@
           <a:lstStyle/>
           <a:p>
             <a:pPr algn="ctr"/>
+            <a:endParaRPr/>
           </a:p>
         </p:txBody>
       </p:sp>
@@ -10690,6 +10992,7 @@
           <a:lstStyle/>
           <a:p>
             <a:pPr algn="ctr"/>
+            <a:endParaRPr/>
           </a:p>
         </p:txBody>
       </p:sp>
@@ -10767,6 +11070,7 @@
           <a:lstStyle/>
           <a:p>
             <a:pPr algn="ctr"/>
+            <a:endParaRPr/>
           </a:p>
         </p:txBody>
       </p:sp>
@@ -10810,6 +11114,7 @@
           <a:lstStyle/>
           <a:p>
             <a:pPr algn="ctr"/>
+            <a:endParaRPr/>
           </a:p>
         </p:txBody>
       </p:sp>
@@ -10921,6 +11226,7 @@
           <a:lstStyle/>
           <a:p>
             <a:pPr algn="ctr"/>
+            <a:endParaRPr/>
           </a:p>
         </p:txBody>
       </p:sp>
@@ -10964,6 +11270,7 @@
           <a:lstStyle/>
           <a:p>
             <a:pPr algn="ctr"/>
+            <a:endParaRPr/>
           </a:p>
         </p:txBody>
       </p:sp>
@@ -11075,6 +11382,7 @@
           <a:lstStyle/>
           <a:p>
             <a:pPr algn="ctr"/>
+            <a:endParaRPr/>
           </a:p>
         </p:txBody>
       </p:sp>
@@ -11118,6 +11426,7 @@
           <a:lstStyle/>
           <a:p>
             <a:pPr algn="ctr"/>
+            <a:endParaRPr/>
           </a:p>
         </p:txBody>
       </p:sp>
@@ -11229,6 +11538,7 @@
           <a:lstStyle/>
           <a:p>
             <a:pPr algn="ctr"/>
+            <a:endParaRPr/>
           </a:p>
         </p:txBody>
       </p:sp>
@@ -11272,6 +11582,7 @@
           <a:lstStyle/>
           <a:p>
             <a:pPr algn="ctr"/>
+            <a:endParaRPr/>
           </a:p>
         </p:txBody>
       </p:sp>
@@ -11383,6 +11694,7 @@
           <a:lstStyle/>
           <a:p>
             <a:pPr algn="ctr"/>
+            <a:endParaRPr/>
           </a:p>
         </p:txBody>
       </p:sp>
@@ -11426,6 +11738,7 @@
           <a:lstStyle/>
           <a:p>
             <a:pPr algn="ctr"/>
+            <a:endParaRPr/>
           </a:p>
         </p:txBody>
       </p:sp>
@@ -11537,6 +11850,7 @@
           <a:lstStyle/>
           <a:p>
             <a:pPr algn="ctr"/>
+            <a:endParaRPr/>
           </a:p>
         </p:txBody>
       </p:sp>
@@ -11580,6 +11894,7 @@
           <a:lstStyle/>
           <a:p>
             <a:pPr algn="ctr"/>
+            <a:endParaRPr/>
           </a:p>
         </p:txBody>
       </p:sp>
@@ -11660,7 +11975,7 @@
 </file>
 
 <file path=ppt/slides/slide16.xml><?xml version="1.0" encoding="utf-8"?>
-<p:sld xmlns:a="http://schemas.openxmlformats.org/drawingml/2006/main" xmlns:p="http://schemas.openxmlformats.org/presentationml/2006/main" xmlns:r="http://schemas.openxmlformats.org/officeDocument/2006/relationships">
+<p:sld xmlns:a="http://schemas.openxmlformats.org/drawingml/2006/main" xmlns:r="http://schemas.openxmlformats.org/officeDocument/2006/relationships" xmlns:p="http://schemas.openxmlformats.org/presentationml/2006/main">
   <p:cSld>
     <p:bg>
       <p:bgPr>
@@ -11676,7 +11991,14 @@
         <p:cNvGrpSpPr/>
         <p:nvPr/>
       </p:nvGrpSpPr>
-      <p:grpSpPr/>
+      <p:grpSpPr>
+        <a:xfrm>
+          <a:off x="0" y="0"/>
+          <a:ext cx="0" cy="0"/>
+          <a:chOff x="0" y="0"/>
+          <a:chExt cx="0" cy="0"/>
+        </a:xfrm>
+      </p:grpSpPr>
       <p:sp>
         <p:nvSpPr>
           <p:cNvPr id="2" name="TextBox 1"/>
@@ -11821,6 +12143,7 @@
           <a:lstStyle/>
           <a:p>
             <a:pPr algn="ctr"/>
+            <a:endParaRPr/>
           </a:p>
         </p:txBody>
       </p:sp>
@@ -11864,6 +12187,7 @@
           <a:lstStyle/>
           <a:p>
             <a:pPr algn="ctr"/>
+            <a:endParaRPr/>
           </a:p>
         </p:txBody>
       </p:sp>
@@ -11978,6 +12302,7 @@
           <a:lstStyle/>
           <a:p>
             <a:pPr algn="ctr"/>
+            <a:endParaRPr/>
           </a:p>
         </p:txBody>
       </p:sp>
@@ -12059,6 +12384,7 @@
           <a:lstStyle/>
           <a:p>
             <a:pPr algn="ctr"/>
+            <a:endParaRPr/>
           </a:p>
         </p:txBody>
       </p:sp>
@@ -12102,6 +12428,7 @@
           <a:lstStyle/>
           <a:p>
             <a:pPr algn="ctr"/>
+            <a:endParaRPr/>
           </a:p>
         </p:txBody>
       </p:sp>
@@ -12217,6 +12544,7 @@
           <a:lstStyle/>
           <a:p>
             <a:pPr algn="ctr"/>
+            <a:endParaRPr/>
           </a:p>
         </p:txBody>
       </p:sp>
@@ -12298,6 +12626,7 @@
           <a:lstStyle/>
           <a:p>
             <a:pPr algn="ctr"/>
+            <a:endParaRPr/>
           </a:p>
         </p:txBody>
       </p:sp>
@@ -12341,6 +12670,7 @@
           <a:lstStyle/>
           <a:p>
             <a:pPr algn="ctr"/>
+            <a:endParaRPr/>
           </a:p>
         </p:txBody>
       </p:sp>
@@ -12455,6 +12785,7 @@
           <a:lstStyle/>
           <a:p>
             <a:pPr algn="ctr"/>
+            <a:endParaRPr/>
           </a:p>
         </p:txBody>
       </p:sp>
@@ -12535,6 +12866,7 @@
           <a:lstStyle/>
           <a:p>
             <a:pPr algn="ctr"/>
+            <a:endParaRPr/>
           </a:p>
         </p:txBody>
       </p:sp>
@@ -12578,6 +12910,7 @@
           <a:lstStyle/>
           <a:p>
             <a:pPr algn="ctr"/>
+            <a:endParaRPr/>
           </a:p>
         </p:txBody>
       </p:sp>
@@ -12693,6 +13026,7 @@
           <a:lstStyle/>
           <a:p>
             <a:pPr algn="ctr"/>
+            <a:endParaRPr/>
           </a:p>
         </p:txBody>
       </p:sp>
@@ -12774,6 +13108,7 @@
           <a:lstStyle/>
           <a:p>
             <a:pPr algn="ctr"/>
+            <a:endParaRPr/>
           </a:p>
         </p:txBody>
       </p:sp>
@@ -12817,6 +13152,7 @@
           <a:lstStyle/>
           <a:p>
             <a:pPr algn="ctr"/>
+            <a:endParaRPr/>
           </a:p>
         </p:txBody>
       </p:sp>
@@ -12931,6 +13267,7 @@
           <a:lstStyle/>
           <a:p>
             <a:pPr algn="ctr"/>
+            <a:endParaRPr/>
           </a:p>
         </p:txBody>
       </p:sp>
@@ -13012,6 +13349,7 @@
           <a:lstStyle/>
           <a:p>
             <a:pPr algn="ctr"/>
+            <a:endParaRPr/>
           </a:p>
         </p:txBody>
       </p:sp>
@@ -13055,6 +13393,7 @@
           <a:lstStyle/>
           <a:p>
             <a:pPr algn="ctr"/>
+            <a:endParaRPr/>
           </a:p>
         </p:txBody>
       </p:sp>
@@ -13169,6 +13508,7 @@
           <a:lstStyle/>
           <a:p>
             <a:pPr algn="ctr"/>
+            <a:endParaRPr/>
           </a:p>
         </p:txBody>
       </p:sp>
@@ -13217,7 +13557,7 @@
 </file>
 
 <file path=ppt/slides/slide17.xml><?xml version="1.0" encoding="utf-8"?>
-<p:sld xmlns:a="http://schemas.openxmlformats.org/drawingml/2006/main" xmlns:p="http://schemas.openxmlformats.org/presentationml/2006/main" xmlns:r="http://schemas.openxmlformats.org/officeDocument/2006/relationships">
+<p:sld xmlns:a="http://schemas.openxmlformats.org/drawingml/2006/main" xmlns:r="http://schemas.openxmlformats.org/officeDocument/2006/relationships" xmlns:p="http://schemas.openxmlformats.org/presentationml/2006/main">
   <p:cSld>
     <p:bg>
       <p:bgPr>
@@ -13233,7 +13573,14 @@
         <p:cNvGrpSpPr/>
         <p:nvPr/>
       </p:nvGrpSpPr>
-      <p:grpSpPr/>
+      <p:grpSpPr>
+        <a:xfrm>
+          <a:off x="0" y="0"/>
+          <a:ext cx="0" cy="0"/>
+          <a:chOff x="0" y="0"/>
+          <a:chExt cx="0" cy="0"/>
+        </a:xfrm>
+      </p:grpSpPr>
       <p:sp>
         <p:nvSpPr>
           <p:cNvPr id="2" name="Rectangle 1"/>
@@ -13274,6 +13621,7 @@
           <a:lstStyle/>
           <a:p>
             <a:pPr algn="ctr"/>
+            <a:endParaRPr/>
           </a:p>
         </p:txBody>
       </p:sp>
@@ -13387,6 +13735,7 @@
           <a:lstStyle/>
           <a:p>
             <a:pPr algn="ctr"/>
+            <a:endParaRPr/>
           </a:p>
         </p:txBody>
       </p:sp>
@@ -13430,6 +13779,7 @@
           <a:lstStyle/>
           <a:p>
             <a:pPr algn="ctr"/>
+            <a:endParaRPr/>
           </a:p>
         </p:txBody>
       </p:sp>
@@ -13543,6 +13893,7 @@
           <a:lstStyle/>
           <a:p>
             <a:pPr algn="ctr"/>
+            <a:endParaRPr/>
           </a:p>
         </p:txBody>
       </p:sp>
@@ -13586,6 +13937,7 @@
           <a:lstStyle/>
           <a:p>
             <a:pPr algn="ctr"/>
+            <a:endParaRPr/>
           </a:p>
         </p:txBody>
       </p:sp>
@@ -13699,6 +14051,7 @@
           <a:lstStyle/>
           <a:p>
             <a:pPr algn="ctr"/>
+            <a:endParaRPr/>
           </a:p>
         </p:txBody>
       </p:sp>
@@ -13742,6 +14095,7 @@
           <a:lstStyle/>
           <a:p>
             <a:pPr algn="ctr"/>
+            <a:endParaRPr/>
           </a:p>
         </p:txBody>
       </p:sp>
@@ -13855,6 +14209,7 @@
           <a:lstStyle/>
           <a:p>
             <a:pPr algn="ctr"/>
+            <a:endParaRPr/>
           </a:p>
         </p:txBody>
       </p:sp>
@@ -13898,6 +14253,7 @@
           <a:lstStyle/>
           <a:p>
             <a:pPr algn="ctr"/>
+            <a:endParaRPr/>
           </a:p>
         </p:txBody>
       </p:sp>
@@ -14011,6 +14367,7 @@
           <a:lstStyle/>
           <a:p>
             <a:pPr algn="ctr"/>
+            <a:endParaRPr/>
           </a:p>
         </p:txBody>
       </p:sp>
@@ -14054,6 +14411,7 @@
           <a:lstStyle/>
           <a:p>
             <a:pPr algn="ctr"/>
+            <a:endParaRPr/>
           </a:p>
         </p:txBody>
       </p:sp>
@@ -14167,6 +14525,7 @@
           <a:lstStyle/>
           <a:p>
             <a:pPr algn="ctr"/>
+            <a:endParaRPr/>
           </a:p>
         </p:txBody>
       </p:sp>
@@ -14210,6 +14569,7 @@
           <a:lstStyle/>
           <a:p>
             <a:pPr algn="ctr"/>
+            <a:endParaRPr/>
           </a:p>
         </p:txBody>
       </p:sp>
@@ -14290,7 +14650,7 @@
 </file>
 
 <file path=ppt/slides/slide18.xml><?xml version="1.0" encoding="utf-8"?>
-<p:sld xmlns:a="http://schemas.openxmlformats.org/drawingml/2006/main" xmlns:p="http://schemas.openxmlformats.org/presentationml/2006/main" xmlns:r="http://schemas.openxmlformats.org/officeDocument/2006/relationships">
+<p:sld xmlns:a="http://schemas.openxmlformats.org/drawingml/2006/main" xmlns:r="http://schemas.openxmlformats.org/officeDocument/2006/relationships" xmlns:p="http://schemas.openxmlformats.org/presentationml/2006/main">
   <p:cSld>
     <p:bg>
       <p:bgPr>
@@ -14306,7 +14666,14 @@
         <p:cNvGrpSpPr/>
         <p:nvPr/>
       </p:nvGrpSpPr>
-      <p:grpSpPr/>
+      <p:grpSpPr>
+        <a:xfrm>
+          <a:off x="0" y="0"/>
+          <a:ext cx="0" cy="0"/>
+          <a:chOff x="0" y="0"/>
+          <a:chExt cx="0" cy="0"/>
+        </a:xfrm>
+      </p:grpSpPr>
       <p:sp>
         <p:nvSpPr>
           <p:cNvPr id="2" name="Rectangle 1"/>
@@ -14347,6 +14714,7 @@
           <a:lstStyle/>
           <a:p>
             <a:pPr algn="ctr"/>
+            <a:endParaRPr/>
           </a:p>
         </p:txBody>
       </p:sp>
@@ -14390,6 +14758,7 @@
           <a:lstStyle/>
           <a:p>
             <a:pPr algn="ctr"/>
+            <a:endParaRPr/>
           </a:p>
         </p:txBody>
       </p:sp>
@@ -14503,6 +14872,7 @@
           <a:lstStyle/>
           <a:p>
             <a:pPr algn="ctr"/>
+            <a:endParaRPr/>
           </a:p>
         </p:txBody>
       </p:sp>
@@ -14616,6 +14986,7 @@
           <a:lstStyle/>
           <a:p>
             <a:pPr algn="ctr"/>
+            <a:endParaRPr/>
           </a:p>
         </p:txBody>
       </p:sp>
@@ -14729,6 +15100,7 @@
           <a:lstStyle/>
           <a:p>
             <a:pPr algn="ctr"/>
+            <a:endParaRPr/>
           </a:p>
         </p:txBody>
       </p:sp>
@@ -14840,6 +15212,7 @@
           <a:lstStyle/>
           <a:p>
             <a:pPr algn="ctr"/>
+            <a:endParaRPr/>
           </a:p>
         </p:txBody>
       </p:sp>
@@ -14879,7 +15252,7 @@
           </a:fontRef>
         </p:style>
         <p:txBody>
-          <a:bodyPr rtlCol="0" anchor="ctr" wrap="none"/>
+          <a:bodyPr wrap="none" rtlCol="0" anchor="ctr"/>
           <a:lstStyle/>
           <a:p>
             <a:pPr algn="ctr"/>
@@ -14930,7 +15303,7 @@
           </a:fontRef>
         </p:style>
         <p:txBody>
-          <a:bodyPr rtlCol="0" anchor="ctr" wrap="none"/>
+          <a:bodyPr wrap="none" rtlCol="0" anchor="ctr"/>
           <a:lstStyle/>
           <a:p>
             <a:pPr algn="ctr"/>
@@ -14981,7 +15354,7 @@
           </a:fontRef>
         </p:style>
         <p:txBody>
-          <a:bodyPr rtlCol="0" anchor="ctr" wrap="none"/>
+          <a:bodyPr wrap="none" rtlCol="0" anchor="ctr"/>
           <a:lstStyle/>
           <a:p>
             <a:pPr algn="ctr"/>
@@ -15005,7 +15378,7 @@
 </file>
 
 <file path=ppt/slides/slide2.xml><?xml version="1.0" encoding="utf-8"?>
-<p:sld xmlns:a="http://schemas.openxmlformats.org/drawingml/2006/main" xmlns:p="http://schemas.openxmlformats.org/presentationml/2006/main" xmlns:r="http://schemas.openxmlformats.org/officeDocument/2006/relationships">
+<p:sld xmlns:a="http://schemas.openxmlformats.org/drawingml/2006/main" xmlns:r="http://schemas.openxmlformats.org/officeDocument/2006/relationships" xmlns:p="http://schemas.openxmlformats.org/presentationml/2006/main">
   <p:cSld>
     <p:bg>
       <p:bgPr>
@@ -15021,7 +15394,14 @@
         <p:cNvGrpSpPr/>
         <p:nvPr/>
       </p:nvGrpSpPr>
-      <p:grpSpPr/>
+      <p:grpSpPr>
+        <a:xfrm>
+          <a:off x="0" y="0"/>
+          <a:ext cx="0" cy="0"/>
+          <a:chOff x="0" y="0"/>
+          <a:chExt cx="0" cy="0"/>
+        </a:xfrm>
+      </p:grpSpPr>
       <p:sp>
         <p:nvSpPr>
           <p:cNvPr id="2" name="Rectangle 1"/>
@@ -15062,6 +15442,7 @@
           <a:lstStyle/>
           <a:p>
             <a:pPr algn="ctr"/>
+            <a:endParaRPr/>
           </a:p>
         </p:txBody>
       </p:sp>
@@ -15105,6 +15486,7 @@
           <a:lstStyle/>
           <a:p>
             <a:pPr algn="ctr"/>
+            <a:endParaRPr/>
           </a:p>
         </p:txBody>
       </p:sp>
@@ -15218,6 +15600,7 @@
           <a:lstStyle/>
           <a:p>
             <a:pPr algn="ctr"/>
+            <a:endParaRPr/>
           </a:p>
         </p:txBody>
       </p:sp>
@@ -15261,6 +15644,7 @@
           <a:lstStyle/>
           <a:p>
             <a:pPr algn="ctr"/>
+            <a:endParaRPr/>
           </a:p>
         </p:txBody>
       </p:sp>
@@ -15375,6 +15759,7 @@
           <a:lstStyle/>
           <a:p>
             <a:pPr algn="ctr"/>
+            <a:endParaRPr/>
           </a:p>
         </p:txBody>
       </p:sp>
@@ -15418,6 +15803,7 @@
           <a:lstStyle/>
           <a:p>
             <a:pPr algn="ctr"/>
+            <a:endParaRPr/>
           </a:p>
         </p:txBody>
       </p:sp>
@@ -15532,6 +15918,7 @@
           <a:lstStyle/>
           <a:p>
             <a:pPr algn="ctr"/>
+            <a:endParaRPr/>
           </a:p>
         </p:txBody>
       </p:sp>
@@ -15575,6 +15962,7 @@
           <a:lstStyle/>
           <a:p>
             <a:pPr algn="ctr"/>
+            <a:endParaRPr/>
           </a:p>
         </p:txBody>
       </p:sp>
@@ -15689,6 +16077,7 @@
           <a:lstStyle/>
           <a:p>
             <a:pPr algn="ctr"/>
+            <a:endParaRPr/>
           </a:p>
         </p:txBody>
       </p:sp>
@@ -15769,7 +16158,7 @@
 </file>
 
 <file path=ppt/slides/slide3.xml><?xml version="1.0" encoding="utf-8"?>
-<p:sld xmlns:a="http://schemas.openxmlformats.org/drawingml/2006/main" xmlns:p="http://schemas.openxmlformats.org/presentationml/2006/main" xmlns:r="http://schemas.openxmlformats.org/officeDocument/2006/relationships">
+<p:sld xmlns:a="http://schemas.openxmlformats.org/drawingml/2006/main" xmlns:r="http://schemas.openxmlformats.org/officeDocument/2006/relationships" xmlns:p="http://schemas.openxmlformats.org/presentationml/2006/main">
   <p:cSld>
     <p:bg>
       <p:bgPr>
@@ -15785,7 +16174,14 @@
         <p:cNvGrpSpPr/>
         <p:nvPr/>
       </p:nvGrpSpPr>
-      <p:grpSpPr/>
+      <p:grpSpPr>
+        <a:xfrm>
+          <a:off x="0" y="0"/>
+          <a:ext cx="0" cy="0"/>
+          <a:chOff x="0" y="0"/>
+          <a:chExt cx="0" cy="0"/>
+        </a:xfrm>
+      </p:grpSpPr>
       <p:sp>
         <p:nvSpPr>
           <p:cNvPr id="2" name="TextBox 1"/>
@@ -15896,6 +16292,7 @@
           <a:lstStyle/>
           <a:p>
             <a:pPr algn="ctr"/>
+            <a:endParaRPr/>
           </a:p>
         </p:txBody>
       </p:sp>
@@ -15939,6 +16336,7 @@
           <a:lstStyle/>
           <a:p>
             <a:pPr algn="ctr"/>
+            <a:endParaRPr/>
           </a:p>
         </p:txBody>
       </p:sp>
@@ -16053,6 +16451,7 @@
           <a:lstStyle/>
           <a:p>
             <a:pPr algn="ctr"/>
+            <a:endParaRPr/>
           </a:p>
         </p:txBody>
       </p:sp>
@@ -16096,6 +16495,7 @@
           <a:lstStyle/>
           <a:p>
             <a:pPr algn="ctr"/>
+            <a:endParaRPr/>
           </a:p>
         </p:txBody>
       </p:sp>
@@ -16210,6 +16610,7 @@
           <a:lstStyle/>
           <a:p>
             <a:pPr algn="ctr"/>
+            <a:endParaRPr/>
           </a:p>
         </p:txBody>
       </p:sp>
@@ -16253,6 +16654,7 @@
           <a:lstStyle/>
           <a:p>
             <a:pPr algn="ctr"/>
+            <a:endParaRPr/>
           </a:p>
         </p:txBody>
       </p:sp>
@@ -16367,6 +16769,7 @@
           <a:lstStyle/>
           <a:p>
             <a:pPr algn="ctr"/>
+            <a:endParaRPr/>
           </a:p>
         </p:txBody>
       </p:sp>
@@ -16410,6 +16813,7 @@
           <a:lstStyle/>
           <a:p>
             <a:pPr algn="ctr"/>
+            <a:endParaRPr/>
           </a:p>
         </p:txBody>
       </p:sp>
@@ -16524,6 +16928,7 @@
           <a:lstStyle/>
           <a:p>
             <a:pPr algn="ctr"/>
+            <a:endParaRPr/>
           </a:p>
         </p:txBody>
       </p:sp>
@@ -16567,6 +16972,7 @@
           <a:lstStyle/>
           <a:p>
             <a:pPr algn="ctr"/>
+            <a:endParaRPr/>
           </a:p>
         </p:txBody>
       </p:sp>
@@ -16681,6 +17087,7 @@
           <a:lstStyle/>
           <a:p>
             <a:pPr algn="ctr"/>
+            <a:endParaRPr/>
           </a:p>
         </p:txBody>
       </p:sp>
@@ -16724,6 +17131,7 @@
           <a:lstStyle/>
           <a:p>
             <a:pPr algn="ctr"/>
+            <a:endParaRPr/>
           </a:p>
         </p:txBody>
       </p:sp>
@@ -16805,7 +17213,7 @@
 </file>
 
 <file path=ppt/slides/slide4.xml><?xml version="1.0" encoding="utf-8"?>
-<p:sld xmlns:a="http://schemas.openxmlformats.org/drawingml/2006/main" xmlns:p="http://schemas.openxmlformats.org/presentationml/2006/main" xmlns:r="http://schemas.openxmlformats.org/officeDocument/2006/relationships">
+<p:sld xmlns:a="http://schemas.openxmlformats.org/drawingml/2006/main" xmlns:r="http://schemas.openxmlformats.org/officeDocument/2006/relationships" xmlns:p="http://schemas.openxmlformats.org/presentationml/2006/main">
   <p:cSld>
     <p:bg>
       <p:bgPr>
@@ -16821,7 +17229,14 @@
         <p:cNvGrpSpPr/>
         <p:nvPr/>
       </p:nvGrpSpPr>
-      <p:grpSpPr/>
+      <p:grpSpPr>
+        <a:xfrm>
+          <a:off x="0" y="0"/>
+          <a:ext cx="0" cy="0"/>
+          <a:chOff x="0" y="0"/>
+          <a:chExt cx="0" cy="0"/>
+        </a:xfrm>
+      </p:grpSpPr>
       <p:sp>
         <p:nvSpPr>
           <p:cNvPr id="2" name="Rectangle 1"/>
@@ -16862,6 +17277,7 @@
           <a:lstStyle/>
           <a:p>
             <a:pPr algn="ctr"/>
+            <a:endParaRPr/>
           </a:p>
         </p:txBody>
       </p:sp>
@@ -16975,6 +17391,7 @@
           <a:lstStyle/>
           <a:p>
             <a:pPr algn="ctr"/>
+            <a:endParaRPr/>
           </a:p>
         </p:txBody>
       </p:sp>
@@ -17018,6 +17435,7 @@
           <a:lstStyle/>
           <a:p>
             <a:pPr algn="ctr"/>
+            <a:endParaRPr/>
           </a:p>
         </p:txBody>
       </p:sp>
@@ -17132,6 +17550,7 @@
           <a:lstStyle/>
           <a:p>
             <a:pPr algn="ctr"/>
+            <a:endParaRPr/>
           </a:p>
         </p:txBody>
       </p:sp>
@@ -17175,6 +17594,7 @@
           <a:lstStyle/>
           <a:p>
             <a:pPr algn="ctr"/>
+            <a:endParaRPr/>
           </a:p>
         </p:txBody>
       </p:sp>
@@ -17289,6 +17709,7 @@
           <a:lstStyle/>
           <a:p>
             <a:pPr algn="ctr"/>
+            <a:endParaRPr/>
           </a:p>
         </p:txBody>
       </p:sp>
@@ -17332,6 +17753,7 @@
           <a:lstStyle/>
           <a:p>
             <a:pPr algn="ctr"/>
+            <a:endParaRPr/>
           </a:p>
         </p:txBody>
       </p:sp>
@@ -17446,6 +17868,7 @@
           <a:lstStyle/>
           <a:p>
             <a:pPr algn="ctr"/>
+            <a:endParaRPr/>
           </a:p>
         </p:txBody>
       </p:sp>
@@ -17489,6 +17912,7 @@
           <a:lstStyle/>
           <a:p>
             <a:pPr algn="ctr"/>
+            <a:endParaRPr/>
           </a:p>
         </p:txBody>
       </p:sp>
@@ -17603,6 +18027,7 @@
           <a:lstStyle/>
           <a:p>
             <a:pPr algn="ctr"/>
+            <a:endParaRPr/>
           </a:p>
         </p:txBody>
       </p:sp>
@@ -18054,7 +18479,7 @@
 </file>
 
 <file path=ppt/slides/slide5.xml><?xml version="1.0" encoding="utf-8"?>
-<p:sld xmlns:a="http://schemas.openxmlformats.org/drawingml/2006/main" xmlns:p="http://schemas.openxmlformats.org/presentationml/2006/main" xmlns:r="http://schemas.openxmlformats.org/officeDocument/2006/relationships">
+<p:sld xmlns:a="http://schemas.openxmlformats.org/drawingml/2006/main" xmlns:r="http://schemas.openxmlformats.org/officeDocument/2006/relationships" xmlns:p="http://schemas.openxmlformats.org/presentationml/2006/main">
   <p:cSld>
     <p:bg>
       <p:bgPr>
@@ -18070,7 +18495,14 @@
         <p:cNvGrpSpPr/>
         <p:nvPr/>
       </p:nvGrpSpPr>
-      <p:grpSpPr/>
+      <p:grpSpPr>
+        <a:xfrm>
+          <a:off x="0" y="0"/>
+          <a:ext cx="0" cy="0"/>
+          <a:chOff x="0" y="0"/>
+          <a:chExt cx="0" cy="0"/>
+        </a:xfrm>
+      </p:grpSpPr>
       <p:sp>
         <p:nvSpPr>
           <p:cNvPr id="2" name="Rectangle 1"/>
@@ -18111,6 +18543,7 @@
           <a:lstStyle/>
           <a:p>
             <a:pPr algn="ctr"/>
+            <a:endParaRPr/>
           </a:p>
         </p:txBody>
       </p:sp>
@@ -18224,6 +18657,7 @@
           <a:lstStyle/>
           <a:p>
             <a:pPr algn="ctr"/>
+            <a:endParaRPr/>
           </a:p>
         </p:txBody>
       </p:sp>
@@ -18541,6 +18975,7 @@
           <a:lstStyle/>
           <a:p>
             <a:pPr algn="ctr"/>
+            <a:endParaRPr/>
           </a:p>
         </p:txBody>
       </p:sp>
@@ -18584,6 +19019,7 @@
           <a:lstStyle/>
           <a:p>
             <a:pPr algn="ctr"/>
+            <a:endParaRPr/>
           </a:p>
         </p:txBody>
       </p:sp>
@@ -18698,6 +19134,7 @@
           <a:lstStyle/>
           <a:p>
             <a:pPr algn="ctr"/>
+            <a:endParaRPr/>
           </a:p>
         </p:txBody>
       </p:sp>
@@ -18741,6 +19178,7 @@
           <a:lstStyle/>
           <a:p>
             <a:pPr algn="ctr"/>
+            <a:endParaRPr/>
           </a:p>
         </p:txBody>
       </p:sp>
@@ -18855,6 +19293,7 @@
           <a:lstStyle/>
           <a:p>
             <a:pPr algn="ctr"/>
+            <a:endParaRPr/>
           </a:p>
         </p:txBody>
       </p:sp>
@@ -18898,6 +19337,7 @@
           <a:lstStyle/>
           <a:p>
             <a:pPr algn="ctr"/>
+            <a:endParaRPr/>
           </a:p>
         </p:txBody>
       </p:sp>
@@ -19012,6 +19452,7 @@
           <a:lstStyle/>
           <a:p>
             <a:pPr algn="ctr"/>
+            <a:endParaRPr/>
           </a:p>
         </p:txBody>
       </p:sp>
@@ -19055,6 +19496,7 @@
           <a:lstStyle/>
           <a:p>
             <a:pPr algn="ctr"/>
+            <a:endParaRPr/>
           </a:p>
         </p:txBody>
       </p:sp>
@@ -19136,7 +19578,7 @@
 </file>
 
 <file path=ppt/slides/slide6.xml><?xml version="1.0" encoding="utf-8"?>
-<p:sld xmlns:a="http://schemas.openxmlformats.org/drawingml/2006/main" xmlns:p="http://schemas.openxmlformats.org/presentationml/2006/main" xmlns:r="http://schemas.openxmlformats.org/officeDocument/2006/relationships">
+<p:sld xmlns:a="http://schemas.openxmlformats.org/drawingml/2006/main" xmlns:r="http://schemas.openxmlformats.org/officeDocument/2006/relationships" xmlns:p="http://schemas.openxmlformats.org/presentationml/2006/main">
   <p:cSld>
     <p:bg>
       <p:bgPr>
@@ -19152,7 +19594,14 @@
         <p:cNvGrpSpPr/>
         <p:nvPr/>
       </p:nvGrpSpPr>
-      <p:grpSpPr/>
+      <p:grpSpPr>
+        <a:xfrm>
+          <a:off x="0" y="0"/>
+          <a:ext cx="0" cy="0"/>
+          <a:chOff x="0" y="0"/>
+          <a:chExt cx="0" cy="0"/>
+        </a:xfrm>
+      </p:grpSpPr>
       <p:sp>
         <p:nvSpPr>
           <p:cNvPr id="2" name="Rectangle 1"/>
@@ -19193,6 +19642,7 @@
           <a:lstStyle/>
           <a:p>
             <a:pPr algn="ctr"/>
+            <a:endParaRPr/>
           </a:p>
         </p:txBody>
       </p:sp>
@@ -19306,6 +19756,7 @@
           <a:lstStyle/>
           <a:p>
             <a:pPr algn="ctr"/>
+            <a:endParaRPr/>
           </a:p>
         </p:txBody>
       </p:sp>
@@ -19379,7 +19830,7 @@
           </a:fontRef>
         </p:style>
         <p:txBody>
-          <a:bodyPr rtlCol="0" anchor="ctr" wrap="none"/>
+          <a:bodyPr wrap="none" rtlCol="0" anchor="ctr"/>
           <a:lstStyle/>
           <a:p>
             <a:pPr algn="ctr"/>
@@ -19430,7 +19881,7 @@
           </a:fontRef>
         </p:style>
         <p:txBody>
-          <a:bodyPr rtlCol="0" anchor="ctr" wrap="none"/>
+          <a:bodyPr wrap="none" rtlCol="0" anchor="ctr"/>
           <a:lstStyle/>
           <a:p>
             <a:pPr algn="ctr"/>
@@ -19481,7 +19932,7 @@
           </a:fontRef>
         </p:style>
         <p:txBody>
-          <a:bodyPr rtlCol="0" anchor="ctr" wrap="none"/>
+          <a:bodyPr wrap="none" rtlCol="0" anchor="ctr"/>
           <a:lstStyle/>
           <a:p>
             <a:pPr algn="ctr"/>
@@ -19532,7 +19983,7 @@
           </a:fontRef>
         </p:style>
         <p:txBody>
-          <a:bodyPr rtlCol="0" anchor="ctr" wrap="none"/>
+          <a:bodyPr wrap="none" rtlCol="0" anchor="ctr"/>
           <a:lstStyle/>
           <a:p>
             <a:pPr algn="ctr"/>
@@ -19583,7 +20034,7 @@
           </a:fontRef>
         </p:style>
         <p:txBody>
-          <a:bodyPr rtlCol="0" anchor="ctr" wrap="none"/>
+          <a:bodyPr wrap="none" rtlCol="0" anchor="ctr"/>
           <a:lstStyle/>
           <a:p>
             <a:pPr algn="ctr"/>
@@ -19674,6 +20125,7 @@
           <a:lstStyle/>
           <a:p>
             <a:pPr algn="ctr"/>
+            <a:endParaRPr/>
           </a:p>
         </p:txBody>
       </p:sp>
@@ -19789,6 +20241,7 @@
           <a:lstStyle/>
           <a:p>
             <a:pPr algn="ctr"/>
+            <a:endParaRPr/>
           </a:p>
         </p:txBody>
       </p:sp>
@@ -19864,7 +20317,7 @@
           </a:fontRef>
         </p:style>
         <p:txBody>
-          <a:bodyPr rtlCol="0" anchor="ctr" wrap="square"/>
+          <a:bodyPr wrap="square" rtlCol="0" anchor="ctr"/>
           <a:lstStyle/>
           <a:p>
             <a:pPr algn="l"/>
@@ -19951,7 +20404,7 @@
           </a:fontRef>
         </p:style>
         <p:txBody>
-          <a:bodyPr rtlCol="0" anchor="ctr" wrap="square"/>
+          <a:bodyPr wrap="square" rtlCol="0" anchor="ctr"/>
           <a:lstStyle/>
           <a:p>
             <a:pPr algn="l"/>
@@ -20038,7 +20491,7 @@
           </a:fontRef>
         </p:style>
         <p:txBody>
-          <a:bodyPr rtlCol="0" anchor="ctr" wrap="square"/>
+          <a:bodyPr wrap="square" rtlCol="0" anchor="ctr"/>
           <a:lstStyle/>
           <a:p>
             <a:pPr algn="l"/>
@@ -20125,7 +20578,7 @@
           </a:fontRef>
         </p:style>
         <p:txBody>
-          <a:bodyPr rtlCol="0" anchor="ctr" wrap="square"/>
+          <a:bodyPr wrap="square" rtlCol="0" anchor="ctr"/>
           <a:lstStyle/>
           <a:p>
             <a:pPr algn="l"/>
@@ -20149,7 +20602,7 @@
 </file>
 
 <file path=ppt/slides/slide7.xml><?xml version="1.0" encoding="utf-8"?>
-<p:sld xmlns:a="http://schemas.openxmlformats.org/drawingml/2006/main" xmlns:p="http://schemas.openxmlformats.org/presentationml/2006/main" xmlns:r="http://schemas.openxmlformats.org/officeDocument/2006/relationships">
+<p:sld xmlns:a="http://schemas.openxmlformats.org/drawingml/2006/main" xmlns:r="http://schemas.openxmlformats.org/officeDocument/2006/relationships" xmlns:p="http://schemas.openxmlformats.org/presentationml/2006/main">
   <p:cSld>
     <p:bg>
       <p:bgPr>
@@ -20165,7 +20618,14 @@
         <p:cNvGrpSpPr/>
         <p:nvPr/>
       </p:nvGrpSpPr>
-      <p:grpSpPr/>
+      <p:grpSpPr>
+        <a:xfrm>
+          <a:off x="0" y="0"/>
+          <a:ext cx="0" cy="0"/>
+          <a:chOff x="0" y="0"/>
+          <a:chExt cx="0" cy="0"/>
+        </a:xfrm>
+      </p:grpSpPr>
       <p:sp>
         <p:nvSpPr>
           <p:cNvPr id="2" name="TextBox 1"/>
@@ -20276,6 +20736,7 @@
           <a:lstStyle/>
           <a:p>
             <a:pPr algn="ctr"/>
+            <a:endParaRPr/>
           </a:p>
         </p:txBody>
       </p:sp>
@@ -20319,6 +20780,7 @@
           <a:lstStyle/>
           <a:p>
             <a:pPr algn="ctr"/>
+            <a:endParaRPr/>
           </a:p>
         </p:txBody>
       </p:sp>
@@ -20433,6 +20895,7 @@
           <a:lstStyle/>
           <a:p>
             <a:pPr algn="ctr"/>
+            <a:endParaRPr/>
           </a:p>
         </p:txBody>
       </p:sp>
@@ -20476,6 +20939,7 @@
           <a:lstStyle/>
           <a:p>
             <a:pPr algn="ctr"/>
+            <a:endParaRPr/>
           </a:p>
         </p:txBody>
       </p:sp>
@@ -20590,6 +21054,7 @@
           <a:lstStyle/>
           <a:p>
             <a:pPr algn="ctr"/>
+            <a:endParaRPr/>
           </a:p>
         </p:txBody>
       </p:sp>
@@ -20633,6 +21098,7 @@
           <a:lstStyle/>
           <a:p>
             <a:pPr algn="ctr"/>
+            <a:endParaRPr/>
           </a:p>
         </p:txBody>
       </p:sp>
@@ -20747,6 +21213,7 @@
           <a:lstStyle/>
           <a:p>
             <a:pPr algn="ctr"/>
+            <a:endParaRPr/>
           </a:p>
         </p:txBody>
       </p:sp>
@@ -20790,6 +21257,7 @@
           <a:lstStyle/>
           <a:p>
             <a:pPr algn="ctr"/>
+            <a:endParaRPr/>
           </a:p>
         </p:txBody>
       </p:sp>
@@ -20904,6 +21372,7 @@
           <a:lstStyle/>
           <a:p>
             <a:pPr algn="ctr"/>
+            <a:endParaRPr/>
           </a:p>
         </p:txBody>
       </p:sp>
@@ -20947,6 +21416,7 @@
           <a:lstStyle/>
           <a:p>
             <a:pPr algn="ctr"/>
+            <a:endParaRPr/>
           </a:p>
         </p:txBody>
       </p:sp>
@@ -21061,6 +21531,7 @@
           <a:lstStyle/>
           <a:p>
             <a:pPr algn="ctr"/>
+            <a:endParaRPr/>
           </a:p>
         </p:txBody>
       </p:sp>
@@ -21104,6 +21575,7 @@
           <a:lstStyle/>
           <a:p>
             <a:pPr algn="ctr"/>
+            <a:endParaRPr/>
           </a:p>
         </p:txBody>
       </p:sp>
@@ -21185,7 +21657,7 @@
 </file>
 
 <file path=ppt/slides/slide8.xml><?xml version="1.0" encoding="utf-8"?>
-<p:sld xmlns:a="http://schemas.openxmlformats.org/drawingml/2006/main" xmlns:p="http://schemas.openxmlformats.org/presentationml/2006/main" xmlns:r="http://schemas.openxmlformats.org/officeDocument/2006/relationships">
+<p:sld xmlns:a="http://schemas.openxmlformats.org/drawingml/2006/main" xmlns:r="http://schemas.openxmlformats.org/officeDocument/2006/relationships" xmlns:p="http://schemas.openxmlformats.org/presentationml/2006/main">
   <p:cSld>
     <p:bg>
       <p:bgPr>
@@ -21201,7 +21673,14 @@
         <p:cNvGrpSpPr/>
         <p:nvPr/>
       </p:nvGrpSpPr>
-      <p:grpSpPr/>
+      <p:grpSpPr>
+        <a:xfrm>
+          <a:off x="0" y="0"/>
+          <a:ext cx="0" cy="0"/>
+          <a:chOff x="0" y="0"/>
+          <a:chExt cx="0" cy="0"/>
+        </a:xfrm>
+      </p:grpSpPr>
       <p:sp>
         <p:nvSpPr>
           <p:cNvPr id="2" name="Rectangle 1"/>
@@ -21242,6 +21721,7 @@
           <a:lstStyle/>
           <a:p>
             <a:pPr algn="ctr"/>
+            <a:endParaRPr/>
           </a:p>
         </p:txBody>
       </p:sp>
@@ -21355,6 +21835,7 @@
           <a:lstStyle/>
           <a:p>
             <a:pPr algn="ctr"/>
+            <a:endParaRPr/>
           </a:p>
         </p:txBody>
       </p:sp>
@@ -21398,6 +21879,7 @@
           <a:lstStyle/>
           <a:p>
             <a:pPr algn="ctr"/>
+            <a:endParaRPr/>
           </a:p>
         </p:txBody>
       </p:sp>
@@ -21512,6 +21994,7 @@
           <a:lstStyle/>
           <a:p>
             <a:pPr algn="ctr"/>
+            <a:endParaRPr/>
           </a:p>
         </p:txBody>
       </p:sp>
@@ -21555,6 +22038,7 @@
           <a:lstStyle/>
           <a:p>
             <a:pPr algn="ctr"/>
+            <a:endParaRPr/>
           </a:p>
         </p:txBody>
       </p:sp>
@@ -21669,6 +22153,7 @@
           <a:lstStyle/>
           <a:p>
             <a:pPr algn="ctr"/>
+            <a:endParaRPr/>
           </a:p>
         </p:txBody>
       </p:sp>
@@ -21712,6 +22197,7 @@
           <a:lstStyle/>
           <a:p>
             <a:pPr algn="ctr"/>
+            <a:endParaRPr/>
           </a:p>
         </p:txBody>
       </p:sp>
@@ -21826,6 +22312,7 @@
           <a:lstStyle/>
           <a:p>
             <a:pPr algn="ctr"/>
+            <a:endParaRPr/>
           </a:p>
         </p:txBody>
       </p:sp>
@@ -21869,6 +22356,7 @@
           <a:lstStyle/>
           <a:p>
             <a:pPr algn="ctr"/>
+            <a:endParaRPr/>
           </a:p>
         </p:txBody>
       </p:sp>
@@ -21983,6 +22471,7 @@
           <a:lstStyle/>
           <a:p>
             <a:pPr algn="ctr"/>
+            <a:endParaRPr/>
           </a:p>
         </p:txBody>
       </p:sp>
@@ -22026,6 +22515,7 @@
           <a:lstStyle/>
           <a:p>
             <a:pPr algn="ctr"/>
+            <a:endParaRPr/>
           </a:p>
         </p:txBody>
       </p:sp>
@@ -22140,6 +22630,7 @@
           <a:lstStyle/>
           <a:p>
             <a:pPr algn="ctr"/>
+            <a:endParaRPr/>
           </a:p>
         </p:txBody>
       </p:sp>
@@ -22183,6 +22674,7 @@
           <a:lstStyle/>
           <a:p>
             <a:pPr algn="ctr"/>
+            <a:endParaRPr/>
           </a:p>
         </p:txBody>
       </p:sp>
@@ -22297,6 +22789,7 @@
           <a:lstStyle/>
           <a:p>
             <a:pPr algn="ctr"/>
+            <a:endParaRPr/>
           </a:p>
         </p:txBody>
       </p:sp>
@@ -22340,6 +22833,7 @@
           <a:lstStyle/>
           <a:p>
             <a:pPr algn="ctr"/>
+            <a:endParaRPr/>
           </a:p>
         </p:txBody>
       </p:sp>
@@ -22421,7 +22915,7 @@
 </file>
 
 <file path=ppt/slides/slide9.xml><?xml version="1.0" encoding="utf-8"?>
-<p:sld xmlns:a="http://schemas.openxmlformats.org/drawingml/2006/main" xmlns:p="http://schemas.openxmlformats.org/presentationml/2006/main" xmlns:r="http://schemas.openxmlformats.org/officeDocument/2006/relationships">
+<p:sld xmlns:a="http://schemas.openxmlformats.org/drawingml/2006/main" xmlns:r="http://schemas.openxmlformats.org/officeDocument/2006/relationships" xmlns:p="http://schemas.openxmlformats.org/presentationml/2006/main">
   <p:cSld>
     <p:bg>
       <p:bgPr>
@@ -22437,7 +22931,14 @@
         <p:cNvGrpSpPr/>
         <p:nvPr/>
       </p:nvGrpSpPr>
-      <p:grpSpPr/>
+      <p:grpSpPr>
+        <a:xfrm>
+          <a:off x="0" y="0"/>
+          <a:ext cx="0" cy="0"/>
+          <a:chOff x="0" y="0"/>
+          <a:chExt cx="0" cy="0"/>
+        </a:xfrm>
+      </p:grpSpPr>
       <p:sp>
         <p:nvSpPr>
           <p:cNvPr id="2" name="Rectangle 1"/>
@@ -22478,6 +22979,7 @@
           <a:lstStyle/>
           <a:p>
             <a:pPr algn="ctr"/>
+            <a:endParaRPr/>
           </a:p>
         </p:txBody>
       </p:sp>
@@ -22591,6 +23093,7 @@
           <a:lstStyle/>
           <a:p>
             <a:pPr algn="ctr"/>
+            <a:endParaRPr/>
           </a:p>
         </p:txBody>
       </p:sp>
@@ -22668,6 +23171,7 @@
           <a:lstStyle/>
           <a:p>
             <a:pPr algn="ctr"/>
+            <a:endParaRPr/>
           </a:p>
         </p:txBody>
       </p:sp>
@@ -22745,6 +23249,7 @@
           <a:lstStyle/>
           <a:p>
             <a:pPr algn="ctr"/>
+            <a:endParaRPr/>
           </a:p>
         </p:txBody>
       </p:sp>
@@ -22822,6 +23327,7 @@
           <a:lstStyle/>
           <a:p>
             <a:pPr algn="ctr"/>
+            <a:endParaRPr/>
           </a:p>
         </p:txBody>
       </p:sp>
@@ -22899,6 +23405,7 @@
           <a:lstStyle/>
           <a:p>
             <a:pPr algn="ctr"/>
+            <a:endParaRPr/>
           </a:p>
         </p:txBody>
       </p:sp>
@@ -22976,6 +23483,7 @@
           <a:lstStyle/>
           <a:p>
             <a:pPr algn="ctr"/>
+            <a:endParaRPr/>
           </a:p>
         </p:txBody>
       </p:sp>
@@ -23053,6 +23561,7 @@
           <a:lstStyle/>
           <a:p>
             <a:pPr algn="ctr"/>
+            <a:endParaRPr/>
           </a:p>
         </p:txBody>
       </p:sp>
@@ -23130,6 +23639,7 @@
           <a:lstStyle/>
           <a:p>
             <a:pPr algn="ctr"/>
+            <a:endParaRPr/>
           </a:p>
         </p:txBody>
       </p:sp>
@@ -23209,6 +23719,7 @@
           <a:lstStyle/>
           <a:p>
             <a:pPr algn="ctr"/>
+            <a:endParaRPr/>
           </a:p>
         </p:txBody>
       </p:sp>
@@ -23286,6 +23797,7 @@
           <a:lstStyle/>
           <a:p>
             <a:pPr algn="ctr"/>
+            <a:endParaRPr/>
           </a:p>
         </p:txBody>
       </p:sp>
@@ -23363,6 +23875,7 @@
           <a:lstStyle/>
           <a:p>
             <a:pPr algn="ctr"/>
+            <a:endParaRPr/>
           </a:p>
         </p:txBody>
       </p:sp>
@@ -23440,6 +23953,7 @@
           <a:lstStyle/>
           <a:p>
             <a:pPr algn="ctr"/>
+            <a:endParaRPr/>
           </a:p>
         </p:txBody>
       </p:sp>
@@ -23517,6 +24031,7 @@
           <a:lstStyle/>
           <a:p>
             <a:pPr algn="ctr"/>
+            <a:endParaRPr/>
           </a:p>
         </p:txBody>
       </p:sp>
@@ -23594,6 +24109,7 @@
           <a:lstStyle/>
           <a:p>
             <a:pPr algn="ctr"/>
+            <a:endParaRPr/>
           </a:p>
         </p:txBody>
       </p:sp>
@@ -23671,6 +24187,7 @@
           <a:lstStyle/>
           <a:p>
             <a:pPr algn="ctr"/>
+            <a:endParaRPr/>
           </a:p>
         </p:txBody>
       </p:sp>
@@ -23748,6 +24265,7 @@
           <a:lstStyle/>
           <a:p>
             <a:pPr algn="ctr"/>
+            <a:endParaRPr/>
           </a:p>
         </p:txBody>
       </p:sp>
@@ -23827,6 +24345,7 @@
           <a:lstStyle/>
           <a:p>
             <a:pPr algn="ctr"/>
+            <a:endParaRPr/>
           </a:p>
         </p:txBody>
       </p:sp>
@@ -23904,6 +24423,7 @@
           <a:lstStyle/>
           <a:p>
             <a:pPr algn="ctr"/>
+            <a:endParaRPr/>
           </a:p>
         </p:txBody>
       </p:sp>
@@ -23981,6 +24501,7 @@
           <a:lstStyle/>
           <a:p>
             <a:pPr algn="ctr"/>
+            <a:endParaRPr/>
           </a:p>
         </p:txBody>
       </p:sp>
@@ -24058,6 +24579,7 @@
           <a:lstStyle/>
           <a:p>
             <a:pPr algn="ctr"/>
+            <a:endParaRPr/>
           </a:p>
         </p:txBody>
       </p:sp>
@@ -24135,6 +24657,7 @@
           <a:lstStyle/>
           <a:p>
             <a:pPr algn="ctr"/>
+            <a:endParaRPr/>
           </a:p>
         </p:txBody>
       </p:sp>
@@ -24212,6 +24735,7 @@
           <a:lstStyle/>
           <a:p>
             <a:pPr algn="ctr"/>
+            <a:endParaRPr/>
           </a:p>
         </p:txBody>
       </p:sp>
@@ -24289,6 +24813,7 @@
           <a:lstStyle/>
           <a:p>
             <a:pPr algn="ctr"/>
+            <a:endParaRPr/>
           </a:p>
         </p:txBody>
       </p:sp>
@@ -24366,6 +24891,7 @@
           <a:lstStyle/>
           <a:p>
             <a:pPr algn="ctr"/>
+            <a:endParaRPr/>
           </a:p>
         </p:txBody>
       </p:sp>

</xml_diff>